<commit_message>
feat: add project scoring methodology and working files, and update pitch deck in deliverables
</commit_message>
<xml_diff>
--- a/deliverables/PayerLens_AI_Pitch_Deck.pptx
+++ b/deliverables/PayerLens_AI_Pitch_Deck.pptx
@@ -12,6 +12,8 @@
     <p:sldId id="260" r:id="rId11"/>
     <p:sldId id="261" r:id="rId12"/>
     <p:sldId id="262" r:id="rId13"/>
+    <p:sldId id="263" r:id="rId14"/>
+    <p:sldId id="264" r:id="rId15"/>
   </p:sldIdLst>
   <p:sldSz cx="12191695" cy="6858000" type="screen4x3"/>
   <p:notesSz cx="6858000" cy="9144000"/>
@@ -12088,6 +12090,3273 @@
                 <a:latin typeface="Calibri"/>
               </a:rPr>
               <a:t>PayerLens AI  •  Novo Nordisk GBS Hackathon 2026</a:t>
+            </a:r>
+          </a:p>
+        </p:txBody>
+      </p:sp>
+    </p:spTree>
+  </p:cSld>
+  <p:clrMapOvr>
+    <a:masterClrMapping/>
+  </p:clrMapOvr>
+</p:sld>
+</file>
+
+<file path=ppt/slides/slide8.xml><?xml version="1.0" encoding="utf-8"?>
+<p:sld xmlns:a="http://schemas.openxmlformats.org/drawingml/2006/main" xmlns:p="http://schemas.openxmlformats.org/presentationml/2006/main" xmlns:r="http://schemas.openxmlformats.org/officeDocument/2006/relationships">
+  <p:cSld>
+    <p:bg>
+      <p:bgPr>
+        <a:solidFill>
+          <a:srgbClr val="FFFFFF"/>
+        </a:solidFill>
+        <a:effectLst/>
+      </p:bgPr>
+    </p:bg>
+    <p:spTree>
+      <p:nvGrpSpPr>
+        <p:cNvPr id="1" name=""/>
+        <p:cNvGrpSpPr/>
+        <p:nvPr/>
+      </p:nvGrpSpPr>
+      <p:grpSpPr/>
+      <p:sp>
+        <p:nvSpPr>
+          <p:cNvPr id="2" name="Rectangle 1"/>
+          <p:cNvSpPr/>
+          <p:nvPr/>
+        </p:nvSpPr>
+        <p:spPr>
+          <a:xfrm>
+            <a:off x="0" y="0"/>
+            <a:ext cx="12191695" cy="1051560"/>
+          </a:xfrm>
+          <a:prstGeom prst="rect">
+            <a:avLst/>
+          </a:prstGeom>
+          <a:solidFill>
+            <a:srgbClr val="00205B"/>
+          </a:solidFill>
+          <a:ln>
+            <a:noFill/>
+          </a:ln>
+          <a:effectLst/>
+        </p:spPr>
+        <p:style>
+          <a:lnRef idx="1">
+            <a:schemeClr val="accent1"/>
+          </a:lnRef>
+          <a:fillRef idx="3">
+            <a:schemeClr val="accent1"/>
+          </a:fillRef>
+          <a:effectRef idx="2">
+            <a:schemeClr val="accent1"/>
+          </a:effectRef>
+          <a:fontRef idx="minor">
+            <a:schemeClr val="lt1"/>
+          </a:fontRef>
+        </p:style>
+        <p:txBody>
+          <a:bodyPr rtlCol="0" anchor="ctr"/>
+          <a:lstStyle/>
+          <a:p>
+            <a:pPr algn="ctr"/>
+          </a:p>
+        </p:txBody>
+      </p:sp>
+      <p:sp>
+        <p:nvSpPr>
+          <p:cNvPr id="3" name="TextBox 2"/>
+          <p:cNvSpPr txBox="1"/>
+          <p:nvPr/>
+        </p:nvSpPr>
+        <p:spPr>
+          <a:xfrm>
+            <a:off x="548640" y="128016"/>
+            <a:ext cx="9144000" cy="274320"/>
+          </a:xfrm>
+          <a:prstGeom prst="rect">
+            <a:avLst/>
+          </a:prstGeom>
+          <a:noFill/>
+        </p:spPr>
+        <p:txBody>
+          <a:bodyPr wrap="square" anchor="t" lIns="0" rIns="0" tIns="0" bIns="0">
+            <a:spAutoFit/>
+          </a:bodyPr>
+          <a:lstStyle/>
+          <a:p>
+            <a:pPr algn="l">
+              <a:lnSpc>
+                <a:spcPct val="100000"/>
+              </a:lnSpc>
+            </a:pPr>
+            <a:r>
+              <a:rPr sz="1200" b="1" i="0">
+                <a:solidFill>
+                  <a:srgbClr val="B9C7E8"/>
+                </a:solidFill>
+                <a:latin typeface="Calibri"/>
+              </a:rPr>
+              <a:t>RESPONSE TO PRE-FINALE REVIEW</a:t>
+            </a:r>
+          </a:p>
+        </p:txBody>
+      </p:sp>
+      <p:sp>
+        <p:nvSpPr>
+          <p:cNvPr id="4" name="TextBox 3"/>
+          <p:cNvSpPr txBox="1"/>
+          <p:nvPr/>
+        </p:nvSpPr>
+        <p:spPr>
+          <a:xfrm>
+            <a:off x="548640" y="384048"/>
+            <a:ext cx="9601200" cy="548640"/>
+          </a:xfrm>
+          <a:prstGeom prst="rect">
+            <a:avLst/>
+          </a:prstGeom>
+          <a:noFill/>
+        </p:spPr>
+        <p:txBody>
+          <a:bodyPr wrap="square" anchor="t" lIns="0" rIns="0" tIns="0" bIns="0">
+            <a:spAutoFit/>
+          </a:bodyPr>
+          <a:lstStyle/>
+          <a:p>
+            <a:pPr algn="l">
+              <a:lnSpc>
+                <a:spcPct val="100000"/>
+              </a:lnSpc>
+            </a:pPr>
+            <a:r>
+              <a:rPr sz="2400" b="1" i="0">
+                <a:solidFill>
+                  <a:srgbClr val="FFFFFF"/>
+                </a:solidFill>
+                <a:latin typeface="Calibri"/>
+              </a:rPr>
+              <a:t>Scoring Methodology: How the Matrix Works</a:t>
+            </a:r>
+          </a:p>
+        </p:txBody>
+      </p:sp>
+      <p:sp>
+        <p:nvSpPr>
+          <p:cNvPr id="5" name="Rounded Rectangle 4"/>
+          <p:cNvSpPr/>
+          <p:nvPr/>
+        </p:nvSpPr>
+        <p:spPr>
+          <a:xfrm>
+            <a:off x="10881360" y="384048"/>
+            <a:ext cx="914400" cy="292608"/>
+          </a:xfrm>
+          <a:prstGeom prst="roundRect">
+            <a:avLst>
+              <a:gd name="adj" fmla="val 50000"/>
+            </a:avLst>
+          </a:prstGeom>
+          <a:solidFill>
+            <a:srgbClr val="059669"/>
+          </a:solidFill>
+          <a:ln>
+            <a:noFill/>
+          </a:ln>
+          <a:effectLst/>
+        </p:spPr>
+        <p:style>
+          <a:lnRef idx="1">
+            <a:schemeClr val="accent1"/>
+          </a:lnRef>
+          <a:fillRef idx="3">
+            <a:schemeClr val="accent1"/>
+          </a:fillRef>
+          <a:effectRef idx="2">
+            <a:schemeClr val="accent1"/>
+          </a:effectRef>
+          <a:fontRef idx="minor">
+            <a:schemeClr val="lt1"/>
+          </a:fontRef>
+        </p:style>
+        <p:txBody>
+          <a:bodyPr rtlCol="0" anchor="ctr" lIns="0" rIns="0" tIns="0" bIns="0"/>
+          <a:lstStyle/>
+          <a:p>
+            <a:pPr algn="ctr"/>
+            <a:r>
+              <a:rPr sz="900" b="1">
+                <a:solidFill>
+                  <a:srgbClr val="FFFFFF"/>
+                </a:solidFill>
+                <a:latin typeface="Calibri"/>
+              </a:rPr>
+              <a:t>APPENDIX</a:t>
+            </a:r>
+          </a:p>
+        </p:txBody>
+      </p:sp>
+      <p:sp>
+        <p:nvSpPr>
+          <p:cNvPr id="6" name="Rectangle 5"/>
+          <p:cNvSpPr/>
+          <p:nvPr/>
+        </p:nvSpPr>
+        <p:spPr>
+          <a:xfrm>
+            <a:off x="0" y="1051560"/>
+            <a:ext cx="12191695" cy="38100"/>
+          </a:xfrm>
+          <a:prstGeom prst="rect">
+            <a:avLst/>
+          </a:prstGeom>
+          <a:solidFill>
+            <a:srgbClr val="059669"/>
+          </a:solidFill>
+          <a:ln>
+            <a:noFill/>
+          </a:ln>
+          <a:effectLst/>
+        </p:spPr>
+        <p:style>
+          <a:lnRef idx="1">
+            <a:schemeClr val="accent1"/>
+          </a:lnRef>
+          <a:fillRef idx="3">
+            <a:schemeClr val="accent1"/>
+          </a:fillRef>
+          <a:effectRef idx="2">
+            <a:schemeClr val="accent1"/>
+          </a:effectRef>
+          <a:fontRef idx="minor">
+            <a:schemeClr val="lt1"/>
+          </a:fontRef>
+        </p:style>
+        <p:txBody>
+          <a:bodyPr rtlCol="0" anchor="ctr"/>
+          <a:lstStyle/>
+          <a:p>
+            <a:pPr algn="ctr"/>
+          </a:p>
+        </p:txBody>
+      </p:sp>
+      <p:sp>
+        <p:nvSpPr>
+          <p:cNvPr id="7" name="TextBox 6"/>
+          <p:cNvSpPr txBox="1"/>
+          <p:nvPr/>
+        </p:nvSpPr>
+        <p:spPr>
+          <a:xfrm>
+            <a:off x="548640" y="1325880"/>
+            <a:ext cx="11064240" cy="365760"/>
+          </a:xfrm>
+          <a:prstGeom prst="rect">
+            <a:avLst/>
+          </a:prstGeom>
+          <a:noFill/>
+        </p:spPr>
+        <p:txBody>
+          <a:bodyPr wrap="square" anchor="t" lIns="0" rIns="0" tIns="0" bIns="0">
+            <a:spAutoFit/>
+          </a:bodyPr>
+          <a:lstStyle/>
+          <a:p>
+            <a:pPr algn="l">
+              <a:lnSpc>
+                <a:spcPct val="100000"/>
+              </a:lnSpc>
+            </a:pPr>
+            <a:r>
+              <a:rPr sz="1300" b="0" i="1">
+                <a:solidFill>
+                  <a:srgbClr val="475569"/>
+                </a:solidFill>
+                <a:latin typeface="Calibri"/>
+              </a:rPr>
+              <a:t>A two-layer architecture: an expert-calibrated rubric sets each scenario's baseline; two computational engines make it live.</a:t>
+            </a:r>
+          </a:p>
+        </p:txBody>
+      </p:sp>
+      <p:sp>
+        <p:nvSpPr>
+          <p:cNvPr id="8" name="TextBox 7"/>
+          <p:cNvSpPr txBox="1"/>
+          <p:nvPr/>
+        </p:nvSpPr>
+        <p:spPr>
+          <a:xfrm>
+            <a:off x="548640" y="1691640"/>
+            <a:ext cx="11064240" cy="274320"/>
+          </a:xfrm>
+          <a:prstGeom prst="rect">
+            <a:avLst/>
+          </a:prstGeom>
+          <a:noFill/>
+        </p:spPr>
+        <p:txBody>
+          <a:bodyPr wrap="square" anchor="t" lIns="0" rIns="0" tIns="0" bIns="0">
+            <a:spAutoFit/>
+          </a:bodyPr>
+          <a:lstStyle/>
+          <a:p>
+            <a:pPr algn="l">
+              <a:lnSpc>
+                <a:spcPct val="100000"/>
+              </a:lnSpc>
+            </a:pPr>
+            <a:r>
+              <a:rPr sz="1000" b="0" i="1">
+                <a:solidFill>
+                  <a:srgbClr val="94A3B8"/>
+                </a:solidFill>
+                <a:latin typeface="Calibri"/>
+              </a:rPr>
+              <a:t>Scenario names below are the drug precedents each was calibrated against — our original submission used generic labels (e.g. “Biomarker-Defined High Risk”); see the accompanying Word document, Section 1.1, for the full naming correspondence.</a:t>
+            </a:r>
+          </a:p>
+        </p:txBody>
+      </p:sp>
+      <p:sp>
+        <p:nvSpPr>
+          <p:cNvPr id="9" name="Rounded Rectangle 8"/>
+          <p:cNvSpPr/>
+          <p:nvPr/>
+        </p:nvSpPr>
+        <p:spPr>
+          <a:xfrm>
+            <a:off x="548640" y="1965960"/>
+            <a:ext cx="11109960" cy="777240"/>
+          </a:xfrm>
+          <a:prstGeom prst="roundRect">
+            <a:avLst>
+              <a:gd name="adj" fmla="val 6000"/>
+            </a:avLst>
+          </a:prstGeom>
+          <a:solidFill>
+            <a:srgbClr val="F8FAFC"/>
+          </a:solidFill>
+          <a:ln w="12700">
+            <a:solidFill>
+              <a:srgbClr val="E2E8F0"/>
+            </a:solidFill>
+          </a:ln>
+          <a:effectLst/>
+        </p:spPr>
+        <p:style>
+          <a:lnRef idx="1">
+            <a:schemeClr val="accent1"/>
+          </a:lnRef>
+          <a:fillRef idx="3">
+            <a:schemeClr val="accent1"/>
+          </a:fillRef>
+          <a:effectRef idx="2">
+            <a:schemeClr val="accent1"/>
+          </a:effectRef>
+          <a:fontRef idx="minor">
+            <a:schemeClr val="lt1"/>
+          </a:fontRef>
+        </p:style>
+        <p:txBody>
+          <a:bodyPr rtlCol="0" anchor="ctr"/>
+          <a:lstStyle/>
+          <a:p>
+            <a:pPr algn="ctr"/>
+          </a:p>
+        </p:txBody>
+      </p:sp>
+      <p:sp>
+        <p:nvSpPr>
+          <p:cNvPr id="10" name="TextBox 9"/>
+          <p:cNvSpPr txBox="1"/>
+          <p:nvPr/>
+        </p:nvSpPr>
+        <p:spPr>
+          <a:xfrm>
+            <a:off x="777240" y="2103120"/>
+            <a:ext cx="10607040" cy="502920"/>
+          </a:xfrm>
+          <a:prstGeom prst="rect">
+            <a:avLst/>
+          </a:prstGeom>
+          <a:noFill/>
+        </p:spPr>
+        <p:txBody>
+          <a:bodyPr wrap="square" anchor="ctr" lIns="0" rIns="0" tIns="0" bIns="0">
+            <a:spAutoFit/>
+          </a:bodyPr>
+          <a:lstStyle/>
+          <a:p>
+            <a:pPr algn="ctr">
+              <a:lnSpc>
+                <a:spcPct val="100000"/>
+              </a:lnSpc>
+            </a:pPr>
+            <a:r>
+              <a:rPr sz="1600" b="1" i="0">
+                <a:solidFill>
+                  <a:srgbClr val="00205B"/>
+                </a:solidFill>
+                <a:latin typeface="Calibri"/>
+              </a:rPr>
+              <a:t>Reimbursement Potential Score  =  ( P + U + C + A + F + E )  −  ( G_impl + G_evid )</a:t>
+            </a:r>
+          </a:p>
+        </p:txBody>
+      </p:sp>
+      <p:graphicFrame>
+        <p:nvGraphicFramePr>
+          <p:cNvPr id="11" name="Table 10"/>
+          <p:cNvGraphicFramePr>
+            <a:graphicFrameLocks noGrp="1"/>
+          </p:cNvGraphicFramePr>
+          <p:nvPr/>
+        </p:nvGraphicFramePr>
+        <p:xfrm>
+          <a:off x="548640" y="2926080"/>
+          <a:ext cx="11109960" cy="2377440"/>
+        </p:xfrm>
+        <a:graphic>
+          <a:graphicData uri="http://schemas.openxmlformats.org/drawingml/2006/table">
+            <a:tbl>
+              <a:tblPr firstRow="1" bandRow="1">
+                <a:tableStyleId>{5C22544A-7EE6-4342-B048-85BDC9FD1C3A}</a:tableStyleId>
+              </a:tblPr>
+              <a:tblGrid>
+                <a:gridCol w="3017520"/>
+                <a:gridCol w="822960"/>
+                <a:gridCol w="3108960"/>
+                <a:gridCol w="4160520"/>
+              </a:tblGrid>
+              <a:tr h="297180">
+                <a:tc>
+                  <a:txBody>
+                    <a:bodyPr/>
+                    <a:lstStyle/>
+                    <a:p>
+                      <a:pPr algn="ctr"/>
+                      <a:r>
+                        <a:rPr sz="1050" b="1">
+                          <a:solidFill>
+                            <a:srgbClr val="FFFFFF"/>
+                          </a:solidFill>
+                          <a:latin typeface="Calibri"/>
+                        </a:rPr>
+                        <a:t>Factor</a:t>
+                      </a:r>
+                    </a:p>
+                  </a:txBody>
+                  <a:tcPr anchor="ctr" marL="38100" marR="38100" marT="25400" marB="25400">
+                    <a:solidFill>
+                      <a:srgbClr val="00205B"/>
+                    </a:solidFill>
+                  </a:tcPr>
+                </a:tc>
+                <a:tc>
+                  <a:txBody>
+                    <a:bodyPr/>
+                    <a:lstStyle/>
+                    <a:p>
+                      <a:pPr algn="ctr"/>
+                      <a:r>
+                        <a:rPr sz="1050" b="1">
+                          <a:solidFill>
+                            <a:srgbClr val="FFFFFF"/>
+                          </a:solidFill>
+                          <a:latin typeface="Calibri"/>
+                        </a:rPr>
+                        <a:t>Scale</a:t>
+                      </a:r>
+                    </a:p>
+                  </a:txBody>
+                  <a:tcPr anchor="ctr" marL="38100" marR="38100" marT="25400" marB="25400">
+                    <a:solidFill>
+                      <a:srgbClr val="00205B"/>
+                    </a:solidFill>
+                  </a:tcPr>
+                </a:tc>
+                <a:tc>
+                  <a:txBody>
+                    <a:bodyPr/>
+                    <a:lstStyle/>
+                    <a:p>
+                      <a:pPr algn="ctr"/>
+                      <a:r>
+                        <a:rPr sz="1050" b="1">
+                          <a:solidFill>
+                            <a:srgbClr val="FFFFFF"/>
+                          </a:solidFill>
+                          <a:latin typeface="Calibri"/>
+                        </a:rPr>
+                        <a:t>What it measures</a:t>
+                      </a:r>
+                    </a:p>
+                  </a:txBody>
+                  <a:tcPr anchor="ctr" marL="38100" marR="38100" marT="25400" marB="25400">
+                    <a:solidFill>
+                      <a:srgbClr val="00205B"/>
+                    </a:solidFill>
+                  </a:tcPr>
+                </a:tc>
+                <a:tc>
+                  <a:txBody>
+                    <a:bodyPr/>
+                    <a:lstStyle/>
+                    <a:p>
+                      <a:pPr algn="ctr"/>
+                      <a:r>
+                        <a:rPr sz="1050" b="1">
+                          <a:solidFill>
+                            <a:srgbClr val="FFFFFF"/>
+                          </a:solidFill>
+                          <a:latin typeface="Calibri"/>
+                        </a:rPr>
+                        <a:t>Evidence it reads</a:t>
+                      </a:r>
+                    </a:p>
+                  </a:txBody>
+                  <a:tcPr anchor="ctr" marL="38100" marR="38100" marT="25400" marB="25400">
+                    <a:solidFill>
+                      <a:srgbClr val="00205B"/>
+                    </a:solidFill>
+                  </a:tcPr>
+                </a:tc>
+              </a:tr>
+              <a:tr h="297180">
+                <a:tc>
+                  <a:txBody>
+                    <a:bodyPr/>
+                    <a:lstStyle/>
+                    <a:p>
+                      <a:pPr algn="ctr"/>
+                      <a:r>
+                        <a:rPr sz="1050" b="0">
+                          <a:solidFill>
+                            <a:srgbClr val="0F172A"/>
+                          </a:solidFill>
+                          <a:latin typeface="Calibri"/>
+                        </a:rPr>
+                        <a:t>P — Patient Opportunity</a:t>
+                      </a:r>
+                    </a:p>
+                  </a:txBody>
+                  <a:tcPr anchor="ctr" marL="38100" marR="38100" marT="12700" marB="12700">
+                    <a:solidFill>
+                      <a:srgbClr val="FFFFFF"/>
+                    </a:solidFill>
+                  </a:tcPr>
+                </a:tc>
+                <a:tc>
+                  <a:txBody>
+                    <a:bodyPr/>
+                    <a:lstStyle/>
+                    <a:p>
+                      <a:pPr algn="ctr"/>
+                      <a:r>
+                        <a:rPr sz="1050" b="0">
+                          <a:solidFill>
+                            <a:srgbClr val="0F172A"/>
+                          </a:solidFill>
+                          <a:latin typeface="Calibri"/>
+                        </a:rPr>
+                        <a:t>0–15</a:t>
+                      </a:r>
+                    </a:p>
+                  </a:txBody>
+                  <a:tcPr anchor="ctr" marL="38100" marR="38100" marT="12700" marB="12700">
+                    <a:solidFill>
+                      <a:srgbClr val="FFFFFF"/>
+                    </a:solidFill>
+                  </a:tcPr>
+                </a:tc>
+                <a:tc>
+                  <a:txBody>
+                    <a:bodyPr/>
+                    <a:lstStyle/>
+                    <a:p>
+                      <a:pPr algn="ctr"/>
+                      <a:r>
+                        <a:rPr sz="1050" b="0">
+                          <a:solidFill>
+                            <a:srgbClr val="0F172A"/>
+                          </a:solidFill>
+                          <a:latin typeface="Calibri"/>
+                        </a:rPr>
+                        <a:t>Eligible population share</a:t>
+                      </a:r>
+                    </a:p>
+                  </a:txBody>
+                  <a:tcPr anchor="ctr" marL="38100" marR="38100" marT="12700" marB="12700">
+                    <a:solidFill>
+                      <a:srgbClr val="FFFFFF"/>
+                    </a:solidFill>
+                  </a:tcPr>
+                </a:tc>
+                <a:tc>
+                  <a:txBody>
+                    <a:bodyPr/>
+                    <a:lstStyle/>
+                    <a:p>
+                      <a:pPr algn="ctr"/>
+                      <a:r>
+                        <a:rPr sz="1050" b="0">
+                          <a:solidFill>
+                            <a:srgbClr val="0F172A"/>
+                          </a:solidFill>
+                          <a:latin typeface="Calibri"/>
+                        </a:rPr>
+                        <a:t>OECD/Eurostat/BHF epidemiology</a:t>
+                      </a:r>
+                    </a:p>
+                  </a:txBody>
+                  <a:tcPr anchor="ctr" marL="38100" marR="38100" marT="12700" marB="12700">
+                    <a:solidFill>
+                      <a:srgbClr val="FFFFFF"/>
+                    </a:solidFill>
+                  </a:tcPr>
+                </a:tc>
+              </a:tr>
+              <a:tr h="297180">
+                <a:tc>
+                  <a:txBody>
+                    <a:bodyPr/>
+                    <a:lstStyle/>
+                    <a:p>
+                      <a:pPr algn="ctr"/>
+                      <a:r>
+                        <a:rPr sz="1050" b="0">
+                          <a:solidFill>
+                            <a:srgbClr val="0F172A"/>
+                          </a:solidFill>
+                          <a:latin typeface="Calibri"/>
+                        </a:rPr>
+                        <a:t>U — Unmet Medical Need</a:t>
+                      </a:r>
+                    </a:p>
+                  </a:txBody>
+                  <a:tcPr anchor="ctr" marL="38100" marR="38100" marT="12700" marB="12700">
+                    <a:solidFill>
+                      <a:srgbClr val="F8FAFC"/>
+                    </a:solidFill>
+                  </a:tcPr>
+                </a:tc>
+                <a:tc>
+                  <a:txBody>
+                    <a:bodyPr/>
+                    <a:lstStyle/>
+                    <a:p>
+                      <a:pPr algn="ctr"/>
+                      <a:r>
+                        <a:rPr sz="1050" b="0">
+                          <a:solidFill>
+                            <a:srgbClr val="0F172A"/>
+                          </a:solidFill>
+                          <a:latin typeface="Calibri"/>
+                        </a:rPr>
+                        <a:t>0–20</a:t>
+                      </a:r>
+                    </a:p>
+                  </a:txBody>
+                  <a:tcPr anchor="ctr" marL="38100" marR="38100" marT="12700" marB="12700">
+                    <a:solidFill>
+                      <a:srgbClr val="F8FAFC"/>
+                    </a:solidFill>
+                  </a:tcPr>
+                </a:tc>
+                <a:tc>
+                  <a:txBody>
+                    <a:bodyPr/>
+                    <a:lstStyle/>
+                    <a:p>
+                      <a:pPr algn="ctr"/>
+                      <a:r>
+                        <a:rPr sz="1050" b="0">
+                          <a:solidFill>
+                            <a:srgbClr val="0F172A"/>
+                          </a:solidFill>
+                          <a:latin typeface="Calibri"/>
+                        </a:rPr>
+                        <a:t>Burden of disease, CV event risk</a:t>
+                      </a:r>
+                    </a:p>
+                  </a:txBody>
+                  <a:tcPr anchor="ctr" marL="38100" marR="38100" marT="12700" marB="12700">
+                    <a:solidFill>
+                      <a:srgbClr val="F8FAFC"/>
+                    </a:solidFill>
+                  </a:tcPr>
+                </a:tc>
+                <a:tc>
+                  <a:txBody>
+                    <a:bodyPr/>
+                    <a:lstStyle/>
+                    <a:p>
+                      <a:pPr algn="ctr"/>
+                      <a:r>
+                        <a:rPr sz="1050" b="0">
+                          <a:solidFill>
+                            <a:srgbClr val="0F172A"/>
+                          </a:solidFill>
+                          <a:latin typeface="Calibri"/>
+                        </a:rPr>
+                        <a:t>ESC 2021 guidelines; NHS HES data</a:t>
+                      </a:r>
+                    </a:p>
+                  </a:txBody>
+                  <a:tcPr anchor="ctr" marL="38100" marR="38100" marT="12700" marB="12700">
+                    <a:solidFill>
+                      <a:srgbClr val="F8FAFC"/>
+                    </a:solidFill>
+                  </a:tcPr>
+                </a:tc>
+              </a:tr>
+              <a:tr h="297180">
+                <a:tc>
+                  <a:txBody>
+                    <a:bodyPr/>
+                    <a:lstStyle/>
+                    <a:p>
+                      <a:pPr algn="ctr"/>
+                      <a:r>
+                        <a:rPr sz="1050" b="0">
+                          <a:solidFill>
+                            <a:srgbClr val="0F172A"/>
+                          </a:solidFill>
+                          <a:latin typeface="Calibri"/>
+                        </a:rPr>
+                        <a:t>C — Clinical Differentiation</a:t>
+                      </a:r>
+                    </a:p>
+                  </a:txBody>
+                  <a:tcPr anchor="ctr" marL="38100" marR="38100" marT="12700" marB="12700">
+                    <a:solidFill>
+                      <a:srgbClr val="FFFFFF"/>
+                    </a:solidFill>
+                  </a:tcPr>
+                </a:tc>
+                <a:tc>
+                  <a:txBody>
+                    <a:bodyPr/>
+                    <a:lstStyle/>
+                    <a:p>
+                      <a:pPr algn="ctr"/>
+                      <a:r>
+                        <a:rPr sz="1050" b="0">
+                          <a:solidFill>
+                            <a:srgbClr val="0F172A"/>
+                          </a:solidFill>
+                          <a:latin typeface="Calibri"/>
+                        </a:rPr>
+                        <a:t>0–25</a:t>
+                      </a:r>
+                    </a:p>
+                  </a:txBody>
+                  <a:tcPr anchor="ctr" marL="38100" marR="38100" marT="12700" marB="12700">
+                    <a:solidFill>
+                      <a:srgbClr val="FFFFFF"/>
+                    </a:solidFill>
+                  </a:tcPr>
+                </a:tc>
+                <a:tc>
+                  <a:txBody>
+                    <a:bodyPr/>
+                    <a:lstStyle/>
+                    <a:p>
+                      <a:pPr algn="ctr"/>
+                      <a:r>
+                        <a:rPr sz="1050" b="0">
+                          <a:solidFill>
+                            <a:srgbClr val="0F172A"/>
+                          </a:solidFill>
+                          <a:latin typeface="Calibri"/>
+                        </a:rPr>
+                        <a:t>Effect size vs. comparator</a:t>
+                      </a:r>
+                    </a:p>
+                  </a:txBody>
+                  <a:tcPr anchor="ctr" marL="38100" marR="38100" marT="12700" marB="12700">
+                    <a:solidFill>
+                      <a:srgbClr val="FFFFFF"/>
+                    </a:solidFill>
+                  </a:tcPr>
+                </a:tc>
+                <a:tc>
+                  <a:txBody>
+                    <a:bodyPr/>
+                    <a:lstStyle/>
+                    <a:p>
+                      <a:pPr algn="ctr"/>
+                      <a:r>
+                        <a:rPr sz="1050" b="0">
+                          <a:solidFill>
+                            <a:srgbClr val="0F172A"/>
+                          </a:solidFill>
+                          <a:latin typeface="Calibri"/>
+                        </a:rPr>
+                        <a:t>Landmark trial hazard ratios</a:t>
+                      </a:r>
+                    </a:p>
+                  </a:txBody>
+                  <a:tcPr anchor="ctr" marL="38100" marR="38100" marT="12700" marB="12700">
+                    <a:solidFill>
+                      <a:srgbClr val="FFFFFF"/>
+                    </a:solidFill>
+                  </a:tcPr>
+                </a:tc>
+              </a:tr>
+              <a:tr h="297180">
+                <a:tc>
+                  <a:txBody>
+                    <a:bodyPr/>
+                    <a:lstStyle/>
+                    <a:p>
+                      <a:pPr algn="ctr"/>
+                      <a:r>
+                        <a:rPr sz="1050" b="0">
+                          <a:solidFill>
+                            <a:srgbClr val="0F172A"/>
+                          </a:solidFill>
+                          <a:latin typeface="Calibri"/>
+                        </a:rPr>
+                        <a:t>A — Country Payer Archetype Alignment</a:t>
+                      </a:r>
+                    </a:p>
+                  </a:txBody>
+                  <a:tcPr anchor="ctr" marL="38100" marR="38100" marT="12700" marB="12700">
+                    <a:solidFill>
+                      <a:srgbClr val="F8FAFC"/>
+                    </a:solidFill>
+                  </a:tcPr>
+                </a:tc>
+                <a:tc>
+                  <a:txBody>
+                    <a:bodyPr/>
+                    <a:lstStyle/>
+                    <a:p>
+                      <a:pPr algn="ctr"/>
+                      <a:r>
+                        <a:rPr sz="1050" b="0">
+                          <a:solidFill>
+                            <a:srgbClr val="0F172A"/>
+                          </a:solidFill>
+                          <a:latin typeface="Calibri"/>
+                        </a:rPr>
+                        <a:t>0–35*</a:t>
+                      </a:r>
+                    </a:p>
+                  </a:txBody>
+                  <a:tcPr anchor="ctr" marL="38100" marR="38100" marT="12700" marB="12700">
+                    <a:solidFill>
+                      <a:srgbClr val="F8FAFC"/>
+                    </a:solidFill>
+                  </a:tcPr>
+                </a:tc>
+                <a:tc>
+                  <a:txBody>
+                    <a:bodyPr/>
+                    <a:lstStyle/>
+                    <a:p>
+                      <a:pPr algn="ctr"/>
+                      <a:r>
+                        <a:rPr sz="1050" b="0">
+                          <a:solidFill>
+                            <a:srgbClr val="0F172A"/>
+                          </a:solidFill>
+                          <a:latin typeface="Calibri"/>
+                        </a:rPr>
+                        <a:t>Fit with THAT agency's decision currency</a:t>
+                      </a:r>
+                    </a:p>
+                  </a:txBody>
+                  <a:tcPr anchor="ctr" marL="38100" marR="38100" marT="12700" marB="12700">
+                    <a:solidFill>
+                      <a:srgbClr val="F8FAFC"/>
+                    </a:solidFill>
+                  </a:tcPr>
+                </a:tc>
+                <a:tc>
+                  <a:txBody>
+                    <a:bodyPr/>
+                    <a:lstStyle/>
+                    <a:p>
+                      <a:pPr algn="ctr"/>
+                      <a:r>
+                        <a:rPr sz="1050" b="0">
+                          <a:solidFill>
+                            <a:srgbClr val="0F172A"/>
+                          </a:solidFill>
+                          <a:latin typeface="Calibri"/>
+                        </a:rPr>
+                        <a:t>NICE ICER / G-BA benefit / HAS SMR-ASMR logic</a:t>
+                      </a:r>
+                    </a:p>
+                  </a:txBody>
+                  <a:tcPr anchor="ctr" marL="38100" marR="38100" marT="12700" marB="12700">
+                    <a:solidFill>
+                      <a:srgbClr val="F8FAFC"/>
+                    </a:solidFill>
+                  </a:tcPr>
+                </a:tc>
+              </a:tr>
+              <a:tr h="297180">
+                <a:tc>
+                  <a:txBody>
+                    <a:bodyPr/>
+                    <a:lstStyle/>
+                    <a:p>
+                      <a:pPr algn="ctr"/>
+                      <a:r>
+                        <a:rPr sz="1050" b="0">
+                          <a:solidFill>
+                            <a:srgbClr val="0F172A"/>
+                          </a:solidFill>
+                          <a:latin typeface="Calibri"/>
+                        </a:rPr>
+                        <a:t>F — Affordability / Budget Fit</a:t>
+                      </a:r>
+                    </a:p>
+                  </a:txBody>
+                  <a:tcPr anchor="ctr" marL="38100" marR="38100" marT="12700" marB="12700">
+                    <a:solidFill>
+                      <a:srgbClr val="FFFFFF"/>
+                    </a:solidFill>
+                  </a:tcPr>
+                </a:tc>
+                <a:tc>
+                  <a:txBody>
+                    <a:bodyPr/>
+                    <a:lstStyle/>
+                    <a:p>
+                      <a:pPr algn="ctr"/>
+                      <a:r>
+                        <a:rPr sz="1050" b="0">
+                          <a:solidFill>
+                            <a:srgbClr val="0F172A"/>
+                          </a:solidFill>
+                          <a:latin typeface="Calibri"/>
+                        </a:rPr>
+                        <a:t>0–10</a:t>
+                      </a:r>
+                    </a:p>
+                  </a:txBody>
+                  <a:tcPr anchor="ctr" marL="38100" marR="38100" marT="12700" marB="12700">
+                    <a:solidFill>
+                      <a:srgbClr val="FFFFFF"/>
+                    </a:solidFill>
+                  </a:tcPr>
+                </a:tc>
+                <a:tc>
+                  <a:txBody>
+                    <a:bodyPr/>
+                    <a:lstStyle/>
+                    <a:p>
+                      <a:pPr algn="ctr"/>
+                      <a:r>
+                        <a:rPr sz="1050" b="0">
+                          <a:solidFill>
+                            <a:srgbClr val="0F172A"/>
+                          </a:solidFill>
+                          <a:latin typeface="Calibri"/>
+                        </a:rPr>
+                        <a:t>Budget impact vs. statutory threshold</a:t>
+                      </a:r>
+                    </a:p>
+                  </a:txBody>
+                  <a:tcPr anchor="ctr" marL="38100" marR="38100" marT="12700" marB="12700">
+                    <a:solidFill>
+                      <a:srgbClr val="FFFFFF"/>
+                    </a:solidFill>
+                  </a:tcPr>
+                </a:tc>
+                <a:tc>
+                  <a:txBody>
+                    <a:bodyPr/>
+                    <a:lstStyle/>
+                    <a:p>
+                      <a:pPr algn="ctr"/>
+                      <a:r>
+                        <a:rPr sz="1050" b="0">
+                          <a:solidFill>
+                            <a:srgbClr val="0F172A"/>
+                          </a:solidFill>
+                          <a:latin typeface="Calibri"/>
+                        </a:rPr>
+                        <a:t>NHS £20m / German €30m / French €20m tests</a:t>
+                      </a:r>
+                    </a:p>
+                  </a:txBody>
+                  <a:tcPr anchor="ctr" marL="38100" marR="38100" marT="12700" marB="12700">
+                    <a:solidFill>
+                      <a:srgbClr val="FFFFFF"/>
+                    </a:solidFill>
+                  </a:tcPr>
+                </a:tc>
+              </a:tr>
+              <a:tr h="297180">
+                <a:tc>
+                  <a:txBody>
+                    <a:bodyPr/>
+                    <a:lstStyle/>
+                    <a:p>
+                      <a:pPr algn="ctr"/>
+                      <a:r>
+                        <a:rPr sz="1050" b="0">
+                          <a:solidFill>
+                            <a:srgbClr val="0F172A"/>
+                          </a:solidFill>
+                          <a:latin typeface="Calibri"/>
+                        </a:rPr>
+                        <a:t>E — Evidence Strength</a:t>
+                      </a:r>
+                    </a:p>
+                  </a:txBody>
+                  <a:tcPr anchor="ctr" marL="38100" marR="38100" marT="12700" marB="12700">
+                    <a:solidFill>
+                      <a:srgbClr val="F8FAFC"/>
+                    </a:solidFill>
+                  </a:tcPr>
+                </a:tc>
+                <a:tc>
+                  <a:txBody>
+                    <a:bodyPr/>
+                    <a:lstStyle/>
+                    <a:p>
+                      <a:pPr algn="ctr"/>
+                      <a:r>
+                        <a:rPr sz="1050" b="0">
+                          <a:solidFill>
+                            <a:srgbClr val="0F172A"/>
+                          </a:solidFill>
+                          <a:latin typeface="Calibri"/>
+                        </a:rPr>
+                        <a:t>0–15</a:t>
+                      </a:r>
+                    </a:p>
+                  </a:txBody>
+                  <a:tcPr anchor="ctr" marL="38100" marR="38100" marT="12700" marB="12700">
+                    <a:solidFill>
+                      <a:srgbClr val="F8FAFC"/>
+                    </a:solidFill>
+                  </a:tcPr>
+                </a:tc>
+                <a:tc>
+                  <a:txBody>
+                    <a:bodyPr/>
+                    <a:lstStyle/>
+                    <a:p>
+                      <a:pPr algn="ctr"/>
+                      <a:r>
+                        <a:rPr sz="1050" b="0">
+                          <a:solidFill>
+                            <a:srgbClr val="0F172A"/>
+                          </a:solidFill>
+                          <a:latin typeface="Calibri"/>
+                        </a:rPr>
+                        <a:t>Trial design rigor</a:t>
+                      </a:r>
+                    </a:p>
+                  </a:txBody>
+                  <a:tcPr anchor="ctr" marL="38100" marR="38100" marT="12700" marB="12700">
+                    <a:solidFill>
+                      <a:srgbClr val="F8FAFC"/>
+                    </a:solidFill>
+                  </a:tcPr>
+                </a:tc>
+                <a:tc>
+                  <a:txBody>
+                    <a:bodyPr/>
+                    <a:lstStyle/>
+                    <a:p>
+                      <a:pPr algn="ctr"/>
+                      <a:r>
+                        <a:rPr sz="1050" b="0">
+                          <a:solidFill>
+                            <a:srgbClr val="0F172A"/>
+                          </a:solidFill>
+                          <a:latin typeface="Calibri"/>
+                        </a:rPr>
+                        <a:t>Trial phase &amp; pre-specification</a:t>
+                      </a:r>
+                    </a:p>
+                  </a:txBody>
+                  <a:tcPr anchor="ctr" marL="38100" marR="38100" marT="12700" marB="12700">
+                    <a:solidFill>
+                      <a:srgbClr val="F8FAFC"/>
+                    </a:solidFill>
+                  </a:tcPr>
+                </a:tc>
+              </a:tr>
+              <a:tr h="297180">
+                <a:tc>
+                  <a:txBody>
+                    <a:bodyPr/>
+                    <a:lstStyle/>
+                    <a:p>
+                      <a:pPr algn="ctr"/>
+                      <a:r>
+                        <a:rPr sz="1050" b="0">
+                          <a:solidFill>
+                            <a:srgbClr val="0F172A"/>
+                          </a:solidFill>
+                          <a:latin typeface="Calibri"/>
+                        </a:rPr>
+                        <a:t>G — Implementation + Evidence-Gap Penalties</a:t>
+                      </a:r>
+                    </a:p>
+                  </a:txBody>
+                  <a:tcPr anchor="ctr" marL="38100" marR="38100" marT="12700" marB="12700">
+                    <a:solidFill>
+                      <a:srgbClr val="FFFFFF"/>
+                    </a:solidFill>
+                  </a:tcPr>
+                </a:tc>
+                <a:tc>
+                  <a:txBody>
+                    <a:bodyPr/>
+                    <a:lstStyle/>
+                    <a:p>
+                      <a:pPr algn="ctr"/>
+                      <a:r>
+                        <a:rPr sz="1050" b="0">
+                          <a:solidFill>
+                            <a:srgbClr val="0F172A"/>
+                          </a:solidFill>
+                          <a:latin typeface="Calibri"/>
+                        </a:rPr>
+                        <a:t>−0 to −35</a:t>
+                      </a:r>
+                    </a:p>
+                  </a:txBody>
+                  <a:tcPr anchor="ctr" marL="38100" marR="38100" marT="12700" marB="12700">
+                    <a:solidFill>
+                      <a:srgbClr val="FFFFFF"/>
+                    </a:solidFill>
+                  </a:tcPr>
+                </a:tc>
+                <a:tc>
+                  <a:txBody>
+                    <a:bodyPr/>
+                    <a:lstStyle/>
+                    <a:p>
+                      <a:pPr algn="ctr"/>
+                      <a:r>
+                        <a:rPr sz="1050" b="0">
+                          <a:solidFill>
+                            <a:srgbClr val="0F172A"/>
+                          </a:solidFill>
+                          <a:latin typeface="Calibri"/>
+                        </a:rPr>
+                        <a:t>Diagnostic friction &amp; unresolved objections</a:t>
+                      </a:r>
+                    </a:p>
+                  </a:txBody>
+                  <a:tcPr anchor="ctr" marL="38100" marR="38100" marT="12700" marB="12700">
+                    <a:solidFill>
+                      <a:srgbClr val="FFFFFF"/>
+                    </a:solidFill>
+                  </a:tcPr>
+                </a:tc>
+                <a:tc>
+                  <a:txBody>
+                    <a:bodyPr/>
+                    <a:lstStyle/>
+                    <a:p>
+                      <a:pPr algn="ctr"/>
+                      <a:r>
+                        <a:rPr sz="1050" b="0">
+                          <a:solidFill>
+                            <a:srgbClr val="0F172A"/>
+                          </a:solidFill>
+                          <a:latin typeface="Calibri"/>
+                        </a:rPr>
+                        <a:t>NICE DAP, G-BA Labor-Richtlinie, French RIHN</a:t>
+                      </a:r>
+                    </a:p>
+                  </a:txBody>
+                  <a:tcPr anchor="ctr" marL="38100" marR="38100" marT="12700" marB="12700">
+                    <a:solidFill>
+                      <a:srgbClr val="FFFFFF"/>
+                    </a:solidFill>
+                  </a:tcPr>
+                </a:tc>
+              </a:tr>
+            </a:tbl>
+          </a:graphicData>
+        </a:graphic>
+      </p:graphicFrame>
+      <p:sp>
+        <p:nvSpPr>
+          <p:cNvPr id="12" name="TextBox 11"/>
+          <p:cNvSpPr txBox="1"/>
+          <p:nvPr/>
+        </p:nvSpPr>
+        <p:spPr>
+          <a:xfrm>
+            <a:off x="548640" y="5440680"/>
+            <a:ext cx="11064240" cy="274320"/>
+          </a:xfrm>
+          <a:prstGeom prst="rect">
+            <a:avLst/>
+          </a:prstGeom>
+          <a:noFill/>
+        </p:spPr>
+        <p:txBody>
+          <a:bodyPr wrap="square" anchor="t" lIns="0" rIns="0" tIns="0" bIns="0">
+            <a:spAutoFit/>
+          </a:bodyPr>
+          <a:lstStyle/>
+          <a:p>
+            <a:pPr algn="l">
+              <a:lnSpc>
+                <a:spcPct val="100000"/>
+              </a:lnSpc>
+            </a:pPr>
+            <a:r>
+              <a:rPr sz="1000" b="0" i="1">
+                <a:solidFill>
+                  <a:srgbClr val="B45309"/>
+                </a:solidFill>
+                <a:latin typeface="Calibri"/>
+              </a:rPr>
+              <a:t>* Corrected from 0–15 in our original deck once we solved for A against our own published probabilities — see next slide.</a:t>
+            </a:r>
+          </a:p>
+        </p:txBody>
+      </p:sp>
+      <p:sp>
+        <p:nvSpPr>
+          <p:cNvPr id="13" name="TextBox 12"/>
+          <p:cNvSpPr txBox="1"/>
+          <p:nvPr/>
+        </p:nvSpPr>
+        <p:spPr>
+          <a:xfrm>
+            <a:off x="548640" y="5852160"/>
+            <a:ext cx="11064240" cy="274320"/>
+          </a:xfrm>
+          <a:prstGeom prst="rect">
+            <a:avLst/>
+          </a:prstGeom>
+          <a:noFill/>
+        </p:spPr>
+        <p:txBody>
+          <a:bodyPr wrap="square" anchor="t" lIns="0" rIns="0" tIns="0" bIns="0">
+            <a:spAutoFit/>
+          </a:bodyPr>
+          <a:lstStyle/>
+          <a:p>
+            <a:pPr algn="l">
+              <a:lnSpc>
+                <a:spcPct val="100000"/>
+              </a:lnSpc>
+            </a:pPr>
+            <a:r>
+              <a:rPr sz="1300" b="1" i="0">
+                <a:solidFill>
+                  <a:srgbClr val="00205B"/>
+                </a:solidFill>
+                <a:latin typeface="Calibri"/>
+              </a:rPr>
+              <a:t>From static score to live app — not equal partners:</a:t>
+            </a:r>
+          </a:p>
+        </p:txBody>
+      </p:sp>
+      <p:sp>
+        <p:nvSpPr>
+          <p:cNvPr id="14" name="TextBox 13"/>
+          <p:cNvSpPr txBox="1"/>
+          <p:nvPr/>
+        </p:nvSpPr>
+        <p:spPr>
+          <a:xfrm>
+            <a:off x="548640" y="6172200"/>
+            <a:ext cx="11064240" cy="457200"/>
+          </a:xfrm>
+          <a:prstGeom prst="rect">
+            <a:avLst/>
+          </a:prstGeom>
+          <a:noFill/>
+        </p:spPr>
+        <p:txBody>
+          <a:bodyPr wrap="square" lIns="0" rIns="0" tIns="0" bIns="0">
+            <a:spAutoFit/>
+          </a:bodyPr>
+          <a:lstStyle/>
+          <a:p>
+            <a:pPr>
+              <a:lnSpc>
+                <a:spcPct val="110000"/>
+              </a:lnSpc>
+              <a:spcAft>
+                <a:spcPts val="600"/>
+              </a:spcAft>
+            </a:pPr>
+            <a:r>
+              <a:rPr sz="1050">
+                <a:solidFill>
+                  <a:srgbClr val="475569"/>
+                </a:solidFill>
+                <a:latin typeface="Calibri"/>
+              </a:rPr>
+              <a:t>•  Our first submission used only the deterministic formula above. We've since added a calibrated ML ensemble (13 features, 1,452 records) that is what the live dashboard actually shows when our backend is reachable; the deterministic formula now runs only as the offline fallback.</a:t>
+            </a:r>
+          </a:p>
+        </p:txBody>
+      </p:sp>
+      <p:sp>
+        <p:nvSpPr>
+          <p:cNvPr id="15" name="TextBox 14"/>
+          <p:cNvSpPr txBox="1"/>
+          <p:nvPr/>
+        </p:nvSpPr>
+        <p:spPr>
+          <a:xfrm>
+            <a:off x="548640" y="6565392"/>
+            <a:ext cx="9144000" cy="256032"/>
+          </a:xfrm>
+          <a:prstGeom prst="rect">
+            <a:avLst/>
+          </a:prstGeom>
+          <a:noFill/>
+        </p:spPr>
+        <p:txBody>
+          <a:bodyPr wrap="square" anchor="t" lIns="0" rIns="0" tIns="0" bIns="0">
+            <a:spAutoFit/>
+          </a:bodyPr>
+          <a:lstStyle/>
+          <a:p>
+            <a:pPr algn="l">
+              <a:lnSpc>
+                <a:spcPct val="100000"/>
+              </a:lnSpc>
+            </a:pPr>
+            <a:r>
+              <a:rPr sz="900" b="0" i="0">
+                <a:solidFill>
+                  <a:srgbClr val="94A3B8"/>
+                </a:solidFill>
+                <a:latin typeface="Calibri"/>
+              </a:rPr>
+              <a:t>PayerLens AI  •  Response to pre-finale review — scoring methodology appendix</a:t>
+            </a:r>
+          </a:p>
+        </p:txBody>
+      </p:sp>
+    </p:spTree>
+  </p:cSld>
+  <p:clrMapOvr>
+    <a:masterClrMapping/>
+  </p:clrMapOvr>
+</p:sld>
+</file>
+
+<file path=ppt/slides/slide9.xml><?xml version="1.0" encoding="utf-8"?>
+<p:sld xmlns:a="http://schemas.openxmlformats.org/drawingml/2006/main" xmlns:p="http://schemas.openxmlformats.org/presentationml/2006/main" xmlns:r="http://schemas.openxmlformats.org/officeDocument/2006/relationships">
+  <p:cSld>
+    <p:bg>
+      <p:bgPr>
+        <a:solidFill>
+          <a:srgbClr val="FFFFFF"/>
+        </a:solidFill>
+        <a:effectLst/>
+      </p:bgPr>
+    </p:bg>
+    <p:spTree>
+      <p:nvGrpSpPr>
+        <p:cNvPr id="1" name=""/>
+        <p:cNvGrpSpPr/>
+        <p:nvPr/>
+      </p:nvGrpSpPr>
+      <p:grpSpPr/>
+      <p:sp>
+        <p:nvSpPr>
+          <p:cNvPr id="2" name="Rectangle 1"/>
+          <p:cNvSpPr/>
+          <p:nvPr/>
+        </p:nvSpPr>
+        <p:spPr>
+          <a:xfrm>
+            <a:off x="0" y="0"/>
+            <a:ext cx="12191695" cy="1051560"/>
+          </a:xfrm>
+          <a:prstGeom prst="rect">
+            <a:avLst/>
+          </a:prstGeom>
+          <a:solidFill>
+            <a:srgbClr val="00205B"/>
+          </a:solidFill>
+          <a:ln>
+            <a:noFill/>
+          </a:ln>
+          <a:effectLst/>
+        </p:spPr>
+        <p:style>
+          <a:lnRef idx="1">
+            <a:schemeClr val="accent1"/>
+          </a:lnRef>
+          <a:fillRef idx="3">
+            <a:schemeClr val="accent1"/>
+          </a:fillRef>
+          <a:effectRef idx="2">
+            <a:schemeClr val="accent1"/>
+          </a:effectRef>
+          <a:fontRef idx="minor">
+            <a:schemeClr val="lt1"/>
+          </a:fontRef>
+        </p:style>
+        <p:txBody>
+          <a:bodyPr rtlCol="0" anchor="ctr"/>
+          <a:lstStyle/>
+          <a:p>
+            <a:pPr algn="ctr"/>
+          </a:p>
+        </p:txBody>
+      </p:sp>
+      <p:sp>
+        <p:nvSpPr>
+          <p:cNvPr id="3" name="TextBox 2"/>
+          <p:cNvSpPr txBox="1"/>
+          <p:nvPr/>
+        </p:nvSpPr>
+        <p:spPr>
+          <a:xfrm>
+            <a:off x="548640" y="128016"/>
+            <a:ext cx="9144000" cy="274320"/>
+          </a:xfrm>
+          <a:prstGeom prst="rect">
+            <a:avLst/>
+          </a:prstGeom>
+          <a:noFill/>
+        </p:spPr>
+        <p:txBody>
+          <a:bodyPr wrap="square" anchor="t" lIns="0" rIns="0" tIns="0" bIns="0">
+            <a:spAutoFit/>
+          </a:bodyPr>
+          <a:lstStyle/>
+          <a:p>
+            <a:pPr algn="l">
+              <a:lnSpc>
+                <a:spcPct val="100000"/>
+              </a:lnSpc>
+            </a:pPr>
+            <a:r>
+              <a:rPr sz="1200" b="1" i="0">
+                <a:solidFill>
+                  <a:srgbClr val="B9C7E8"/>
+                </a:solidFill>
+                <a:latin typeface="Calibri"/>
+              </a:rPr>
+              <a:t>RESPONSE TO PRE-FINALE REVIEW</a:t>
+            </a:r>
+          </a:p>
+        </p:txBody>
+      </p:sp>
+      <p:sp>
+        <p:nvSpPr>
+          <p:cNvPr id="4" name="TextBox 3"/>
+          <p:cNvSpPr txBox="1"/>
+          <p:nvPr/>
+        </p:nvSpPr>
+        <p:spPr>
+          <a:xfrm>
+            <a:off x="548640" y="384048"/>
+            <a:ext cx="9601200" cy="548640"/>
+          </a:xfrm>
+          <a:prstGeom prst="rect">
+            <a:avLst/>
+          </a:prstGeom>
+          <a:noFill/>
+        </p:spPr>
+        <p:txBody>
+          <a:bodyPr wrap="square" anchor="t" lIns="0" rIns="0" tIns="0" bIns="0">
+            <a:spAutoFit/>
+          </a:bodyPr>
+          <a:lstStyle/>
+          <a:p>
+            <a:pPr algn="l">
+              <a:lnSpc>
+                <a:spcPct val="100000"/>
+              </a:lnSpc>
+            </a:pPr>
+            <a:r>
+              <a:rPr sz="2400" b="1" i="0">
+                <a:solidFill>
+                  <a:srgbClr val="FFFFFF"/>
+                </a:solidFill>
+                <a:latin typeface="Calibri"/>
+              </a:rPr>
+              <a:t>Reconciled Scoring Component Matrix</a:t>
+            </a:r>
+          </a:p>
+        </p:txBody>
+      </p:sp>
+      <p:sp>
+        <p:nvSpPr>
+          <p:cNvPr id="5" name="Rounded Rectangle 4"/>
+          <p:cNvSpPr/>
+          <p:nvPr/>
+        </p:nvSpPr>
+        <p:spPr>
+          <a:xfrm>
+            <a:off x="10881360" y="384048"/>
+            <a:ext cx="914400" cy="292608"/>
+          </a:xfrm>
+          <a:prstGeom prst="roundRect">
+            <a:avLst>
+              <a:gd name="adj" fmla="val 50000"/>
+            </a:avLst>
+          </a:prstGeom>
+          <a:solidFill>
+            <a:srgbClr val="059669"/>
+          </a:solidFill>
+          <a:ln>
+            <a:noFill/>
+          </a:ln>
+          <a:effectLst/>
+        </p:spPr>
+        <p:style>
+          <a:lnRef idx="1">
+            <a:schemeClr val="accent1"/>
+          </a:lnRef>
+          <a:fillRef idx="3">
+            <a:schemeClr val="accent1"/>
+          </a:fillRef>
+          <a:effectRef idx="2">
+            <a:schemeClr val="accent1"/>
+          </a:effectRef>
+          <a:fontRef idx="minor">
+            <a:schemeClr val="lt1"/>
+          </a:fontRef>
+        </p:style>
+        <p:txBody>
+          <a:bodyPr rtlCol="0" anchor="ctr" lIns="0" rIns="0" tIns="0" bIns="0"/>
+          <a:lstStyle/>
+          <a:p>
+            <a:pPr algn="ctr"/>
+            <a:r>
+              <a:rPr sz="900" b="1">
+                <a:solidFill>
+                  <a:srgbClr val="FFFFFF"/>
+                </a:solidFill>
+                <a:latin typeface="Calibri"/>
+              </a:rPr>
+              <a:t>APPENDIX</a:t>
+            </a:r>
+          </a:p>
+        </p:txBody>
+      </p:sp>
+      <p:sp>
+        <p:nvSpPr>
+          <p:cNvPr id="6" name="Rectangle 5"/>
+          <p:cNvSpPr/>
+          <p:nvPr/>
+        </p:nvSpPr>
+        <p:spPr>
+          <a:xfrm>
+            <a:off x="0" y="1051560"/>
+            <a:ext cx="12191695" cy="38100"/>
+          </a:xfrm>
+          <a:prstGeom prst="rect">
+            <a:avLst/>
+          </a:prstGeom>
+          <a:solidFill>
+            <a:srgbClr val="059669"/>
+          </a:solidFill>
+          <a:ln>
+            <a:noFill/>
+          </a:ln>
+          <a:effectLst/>
+        </p:spPr>
+        <p:style>
+          <a:lnRef idx="1">
+            <a:schemeClr val="accent1"/>
+          </a:lnRef>
+          <a:fillRef idx="3">
+            <a:schemeClr val="accent1"/>
+          </a:fillRef>
+          <a:effectRef idx="2">
+            <a:schemeClr val="accent1"/>
+          </a:effectRef>
+          <a:fontRef idx="minor">
+            <a:schemeClr val="lt1"/>
+          </a:fontRef>
+        </p:style>
+        <p:txBody>
+          <a:bodyPr rtlCol="0" anchor="ctr"/>
+          <a:lstStyle/>
+          <a:p>
+            <a:pPr algn="ctr"/>
+          </a:p>
+        </p:txBody>
+      </p:sp>
+      <p:sp>
+        <p:nvSpPr>
+          <p:cNvPr id="7" name="TextBox 6"/>
+          <p:cNvSpPr txBox="1"/>
+          <p:nvPr/>
+        </p:nvSpPr>
+        <p:spPr>
+          <a:xfrm>
+            <a:off x="548640" y="1280160"/>
+            <a:ext cx="11064240" cy="548640"/>
+          </a:xfrm>
+          <a:prstGeom prst="rect">
+            <a:avLst/>
+          </a:prstGeom>
+          <a:noFill/>
+        </p:spPr>
+        <p:txBody>
+          <a:bodyPr wrap="square" anchor="t" lIns="0" rIns="0" tIns="0" bIns="0">
+            <a:spAutoFit/>
+          </a:bodyPr>
+          <a:lstStyle/>
+          <a:p>
+            <a:pPr algn="l">
+              <a:lnSpc>
+                <a:spcPct val="100000"/>
+              </a:lnSpc>
+            </a:pPr>
+            <a:r>
+              <a:rPr sz="1250" b="0" i="1">
+                <a:solidFill>
+                  <a:srgbClr val="475569"/>
+                </a:solidFill>
+                <a:latin typeface="Calibri"/>
+              </a:rPr>
+              <a:t>Every cell below sums exactly to the calibrated probability in our Scenario Evaluation Matrix — P, U, C, F, E and G are scenario-level; A is the only country-dependent term.</a:t>
+            </a:r>
+          </a:p>
+        </p:txBody>
+      </p:sp>
+      <p:graphicFrame>
+        <p:nvGraphicFramePr>
+          <p:cNvPr id="8" name="Table 7"/>
+          <p:cNvGraphicFramePr>
+            <a:graphicFrameLocks noGrp="1"/>
+          </p:cNvGraphicFramePr>
+          <p:nvPr/>
+        </p:nvGraphicFramePr>
+        <p:xfrm>
+          <a:off x="365760" y="1965960"/>
+          <a:ext cx="11494008" cy="2926080"/>
+        </p:xfrm>
+        <a:graphic>
+          <a:graphicData uri="http://schemas.openxmlformats.org/drawingml/2006/table">
+            <a:tbl>
+              <a:tblPr firstRow="1" bandRow="1">
+                <a:tableStyleId>{5C22544A-7EE6-4342-B048-85BDC9FD1C3A}</a:tableStyleId>
+              </a:tblPr>
+              <a:tblGrid>
+                <a:gridCol w="3429000"/>
+                <a:gridCol w="603504"/>
+                <a:gridCol w="603504"/>
+                <a:gridCol w="603504"/>
+                <a:gridCol w="1618488"/>
+                <a:gridCol w="603504"/>
+                <a:gridCol w="603504"/>
+                <a:gridCol w="905256"/>
+                <a:gridCol w="905256"/>
+                <a:gridCol w="1618488"/>
+              </a:tblGrid>
+              <a:tr h="487680">
+                <a:tc>
+                  <a:txBody>
+                    <a:bodyPr/>
+                    <a:lstStyle/>
+                    <a:p>
+                      <a:pPr algn="ctr"/>
+                      <a:r>
+                        <a:rPr sz="1050" b="1">
+                          <a:solidFill>
+                            <a:srgbClr val="FFFFFF"/>
+                          </a:solidFill>
+                          <a:latin typeface="Calibri"/>
+                        </a:rPr>
+                        <a:t>Scenario</a:t>
+                      </a:r>
+                    </a:p>
+                  </a:txBody>
+                  <a:tcPr anchor="ctr" marL="38100" marR="38100" marT="25400" marB="25400">
+                    <a:solidFill>
+                      <a:srgbClr val="00205B"/>
+                    </a:solidFill>
+                  </a:tcPr>
+                </a:tc>
+                <a:tc>
+                  <a:txBody>
+                    <a:bodyPr/>
+                    <a:lstStyle/>
+                    <a:p>
+                      <a:pPr algn="ctr"/>
+                      <a:r>
+                        <a:rPr sz="1050" b="1">
+                          <a:solidFill>
+                            <a:srgbClr val="FFFFFF"/>
+                          </a:solidFill>
+                          <a:latin typeface="Calibri"/>
+                        </a:rPr>
+                        <a:t>P</a:t>
+                      </a:r>
+                    </a:p>
+                  </a:txBody>
+                  <a:tcPr anchor="ctr" marL="38100" marR="38100" marT="25400" marB="25400">
+                    <a:solidFill>
+                      <a:srgbClr val="00205B"/>
+                    </a:solidFill>
+                  </a:tcPr>
+                </a:tc>
+                <a:tc>
+                  <a:txBody>
+                    <a:bodyPr/>
+                    <a:lstStyle/>
+                    <a:p>
+                      <a:pPr algn="ctr"/>
+                      <a:r>
+                        <a:rPr sz="1050" b="1">
+                          <a:solidFill>
+                            <a:srgbClr val="FFFFFF"/>
+                          </a:solidFill>
+                          <a:latin typeface="Calibri"/>
+                        </a:rPr>
+                        <a:t>U</a:t>
+                      </a:r>
+                    </a:p>
+                  </a:txBody>
+                  <a:tcPr anchor="ctr" marL="38100" marR="38100" marT="25400" marB="25400">
+                    <a:solidFill>
+                      <a:srgbClr val="00205B"/>
+                    </a:solidFill>
+                  </a:tcPr>
+                </a:tc>
+                <a:tc>
+                  <a:txBody>
+                    <a:bodyPr/>
+                    <a:lstStyle/>
+                    <a:p>
+                      <a:pPr algn="ctr"/>
+                      <a:r>
+                        <a:rPr sz="1050" b="1">
+                          <a:solidFill>
+                            <a:srgbClr val="FFFFFF"/>
+                          </a:solidFill>
+                          <a:latin typeface="Calibri"/>
+                        </a:rPr>
+                        <a:t>C</a:t>
+                      </a:r>
+                    </a:p>
+                  </a:txBody>
+                  <a:tcPr anchor="ctr" marL="38100" marR="38100" marT="25400" marB="25400">
+                    <a:solidFill>
+                      <a:srgbClr val="00205B"/>
+                    </a:solidFill>
+                  </a:tcPr>
+                </a:tc>
+                <a:tc>
+                  <a:txBody>
+                    <a:bodyPr/>
+                    <a:lstStyle/>
+                    <a:p>
+                      <a:pPr algn="ctr"/>
+                      <a:r>
+                        <a:rPr sz="1050" b="1">
+                          <a:solidFill>
+                            <a:srgbClr val="FFFFFF"/>
+                          </a:solidFill>
+                          <a:latin typeface="Calibri"/>
+                        </a:rPr>
+                        <a:t>A (UK/DE/FR)</a:t>
+                      </a:r>
+                    </a:p>
+                  </a:txBody>
+                  <a:tcPr anchor="ctr" marL="38100" marR="38100" marT="25400" marB="25400">
+                    <a:solidFill>
+                      <a:srgbClr val="00205B"/>
+                    </a:solidFill>
+                  </a:tcPr>
+                </a:tc>
+                <a:tc>
+                  <a:txBody>
+                    <a:bodyPr/>
+                    <a:lstStyle/>
+                    <a:p>
+                      <a:pPr algn="ctr"/>
+                      <a:r>
+                        <a:rPr sz="1050" b="1">
+                          <a:solidFill>
+                            <a:srgbClr val="FFFFFF"/>
+                          </a:solidFill>
+                          <a:latin typeface="Calibri"/>
+                        </a:rPr>
+                        <a:t>F</a:t>
+                      </a:r>
+                    </a:p>
+                  </a:txBody>
+                  <a:tcPr anchor="ctr" marL="38100" marR="38100" marT="25400" marB="25400">
+                    <a:solidFill>
+                      <a:srgbClr val="00205B"/>
+                    </a:solidFill>
+                  </a:tcPr>
+                </a:tc>
+                <a:tc>
+                  <a:txBody>
+                    <a:bodyPr/>
+                    <a:lstStyle/>
+                    <a:p>
+                      <a:pPr algn="ctr"/>
+                      <a:r>
+                        <a:rPr sz="1050" b="1">
+                          <a:solidFill>
+                            <a:srgbClr val="FFFFFF"/>
+                          </a:solidFill>
+                          <a:latin typeface="Calibri"/>
+                        </a:rPr>
+                        <a:t>E</a:t>
+                      </a:r>
+                    </a:p>
+                  </a:txBody>
+                  <a:tcPr anchor="ctr" marL="38100" marR="38100" marT="25400" marB="25400">
+                    <a:solidFill>
+                      <a:srgbClr val="00205B"/>
+                    </a:solidFill>
+                  </a:tcPr>
+                </a:tc>
+                <a:tc>
+                  <a:txBody>
+                    <a:bodyPr/>
+                    <a:lstStyle/>
+                    <a:p>
+                      <a:pPr algn="ctr"/>
+                      <a:r>
+                        <a:rPr sz="1050" b="1">
+                          <a:solidFill>
+                            <a:srgbClr val="FFFFFF"/>
+                          </a:solidFill>
+                          <a:latin typeface="Calibri"/>
+                        </a:rPr>
+                        <a:t>G_impl</a:t>
+                      </a:r>
+                    </a:p>
+                  </a:txBody>
+                  <a:tcPr anchor="ctr" marL="38100" marR="38100" marT="25400" marB="25400">
+                    <a:solidFill>
+                      <a:srgbClr val="00205B"/>
+                    </a:solidFill>
+                  </a:tcPr>
+                </a:tc>
+                <a:tc>
+                  <a:txBody>
+                    <a:bodyPr/>
+                    <a:lstStyle/>
+                    <a:p>
+                      <a:pPr algn="ctr"/>
+                      <a:r>
+                        <a:rPr sz="1050" b="1">
+                          <a:solidFill>
+                            <a:srgbClr val="FFFFFF"/>
+                          </a:solidFill>
+                          <a:latin typeface="Calibri"/>
+                        </a:rPr>
+                        <a:t>G_evid</a:t>
+                      </a:r>
+                    </a:p>
+                  </a:txBody>
+                  <a:tcPr anchor="ctr" marL="38100" marR="38100" marT="25400" marB="25400">
+                    <a:solidFill>
+                      <a:srgbClr val="00205B"/>
+                    </a:solidFill>
+                  </a:tcPr>
+                </a:tc>
+                <a:tc>
+                  <a:txBody>
+                    <a:bodyPr/>
+                    <a:lstStyle/>
+                    <a:p>
+                      <a:pPr algn="ctr"/>
+                      <a:r>
+                        <a:rPr sz="1050" b="1">
+                          <a:solidFill>
+                            <a:srgbClr val="FFFFFF"/>
+                          </a:solidFill>
+                          <a:latin typeface="Calibri"/>
+                        </a:rPr>
+                        <a:t>Score (UK/DE/FR)</a:t>
+                      </a:r>
+                    </a:p>
+                  </a:txBody>
+                  <a:tcPr anchor="ctr" marL="38100" marR="38100" marT="25400" marB="25400">
+                    <a:solidFill>
+                      <a:srgbClr val="00205B"/>
+                    </a:solidFill>
+                  </a:tcPr>
+                </a:tc>
+              </a:tr>
+              <a:tr h="487680">
+                <a:tc>
+                  <a:txBody>
+                    <a:bodyPr/>
+                    <a:lstStyle/>
+                    <a:p>
+                      <a:pPr algn="ctr"/>
+                      <a:r>
+                        <a:rPr sz="1050" b="0">
+                          <a:solidFill>
+                            <a:srgbClr val="0F172A"/>
+                          </a:solidFill>
+                          <a:latin typeface="Calibri"/>
+                        </a:rPr>
+                        <a:t>Farxiga (D) — Biomarker-Defined High Risk</a:t>
+                      </a:r>
+                    </a:p>
+                  </a:txBody>
+                  <a:tcPr anchor="ctr" marL="38100" marR="38100" marT="12700" marB="12700">
+                    <a:solidFill>
+                      <a:srgbClr val="FFFFFF"/>
+                    </a:solidFill>
+                  </a:tcPr>
+                </a:tc>
+                <a:tc>
+                  <a:txBody>
+                    <a:bodyPr/>
+                    <a:lstStyle/>
+                    <a:p>
+                      <a:pPr algn="ctr"/>
+                      <a:r>
+                        <a:rPr sz="1050" b="0">
+                          <a:solidFill>
+                            <a:srgbClr val="0F172A"/>
+                          </a:solidFill>
+                          <a:latin typeface="Calibri"/>
+                        </a:rPr>
+                        <a:t>8</a:t>
+                      </a:r>
+                    </a:p>
+                  </a:txBody>
+                  <a:tcPr anchor="ctr" marL="38100" marR="38100" marT="12700" marB="12700">
+                    <a:solidFill>
+                      <a:srgbClr val="FFFFFF"/>
+                    </a:solidFill>
+                  </a:tcPr>
+                </a:tc>
+                <a:tc>
+                  <a:txBody>
+                    <a:bodyPr/>
+                    <a:lstStyle/>
+                    <a:p>
+                      <a:pPr algn="ctr"/>
+                      <a:r>
+                        <a:rPr sz="1050" b="0">
+                          <a:solidFill>
+                            <a:srgbClr val="0F172A"/>
+                          </a:solidFill>
+                          <a:latin typeface="Calibri"/>
+                        </a:rPr>
+                        <a:t>18</a:t>
+                      </a:r>
+                    </a:p>
+                  </a:txBody>
+                  <a:tcPr anchor="ctr" marL="38100" marR="38100" marT="12700" marB="12700">
+                    <a:solidFill>
+                      <a:srgbClr val="FFFFFF"/>
+                    </a:solidFill>
+                  </a:tcPr>
+                </a:tc>
+                <a:tc>
+                  <a:txBody>
+                    <a:bodyPr/>
+                    <a:lstStyle/>
+                    <a:p>
+                      <a:pPr algn="ctr"/>
+                      <a:r>
+                        <a:rPr sz="1050" b="0">
+                          <a:solidFill>
+                            <a:srgbClr val="0F172A"/>
+                          </a:solidFill>
+                          <a:latin typeface="Calibri"/>
+                        </a:rPr>
+                        <a:t>22</a:t>
+                      </a:r>
+                    </a:p>
+                  </a:txBody>
+                  <a:tcPr anchor="ctr" marL="38100" marR="38100" marT="12700" marB="12700">
+                    <a:solidFill>
+                      <a:srgbClr val="FFFFFF"/>
+                    </a:solidFill>
+                  </a:tcPr>
+                </a:tc>
+                <a:tc>
+                  <a:txBody>
+                    <a:bodyPr/>
+                    <a:lstStyle/>
+                    <a:p>
+                      <a:pPr algn="ctr"/>
+                      <a:r>
+                        <a:rPr sz="1050" b="0">
+                          <a:solidFill>
+                            <a:srgbClr val="0F172A"/>
+                          </a:solidFill>
+                          <a:latin typeface="Calibri"/>
+                        </a:rPr>
+                        <a:t>27/32/31</a:t>
+                      </a:r>
+                    </a:p>
+                  </a:txBody>
+                  <a:tcPr anchor="ctr" marL="38100" marR="38100" marT="12700" marB="12700">
+                    <a:solidFill>
+                      <a:srgbClr val="FFFFFF"/>
+                    </a:solidFill>
+                  </a:tcPr>
+                </a:tc>
+                <a:tc>
+                  <a:txBody>
+                    <a:bodyPr/>
+                    <a:lstStyle/>
+                    <a:p>
+                      <a:pPr algn="ctr"/>
+                      <a:r>
+                        <a:rPr sz="1050" b="0">
+                          <a:solidFill>
+                            <a:srgbClr val="0F172A"/>
+                          </a:solidFill>
+                          <a:latin typeface="Calibri"/>
+                        </a:rPr>
+                        <a:t>8</a:t>
+                      </a:r>
+                    </a:p>
+                  </a:txBody>
+                  <a:tcPr anchor="ctr" marL="38100" marR="38100" marT="12700" marB="12700">
+                    <a:solidFill>
+                      <a:srgbClr val="FFFFFF"/>
+                    </a:solidFill>
+                  </a:tcPr>
+                </a:tc>
+                <a:tc>
+                  <a:txBody>
+                    <a:bodyPr/>
+                    <a:lstStyle/>
+                    <a:p>
+                      <a:pPr algn="ctr"/>
+                      <a:r>
+                        <a:rPr sz="1050" b="0">
+                          <a:solidFill>
+                            <a:srgbClr val="0F172A"/>
+                          </a:solidFill>
+                          <a:latin typeface="Calibri"/>
+                        </a:rPr>
+                        <a:t>15</a:t>
+                      </a:r>
+                    </a:p>
+                  </a:txBody>
+                  <a:tcPr anchor="ctr" marL="38100" marR="38100" marT="12700" marB="12700">
+                    <a:solidFill>
+                      <a:srgbClr val="FFFFFF"/>
+                    </a:solidFill>
+                  </a:tcPr>
+                </a:tc>
+                <a:tc>
+                  <a:txBody>
+                    <a:bodyPr/>
+                    <a:lstStyle/>
+                    <a:p>
+                      <a:pPr algn="ctr"/>
+                      <a:r>
+                        <a:rPr sz="1050" b="0">
+                          <a:solidFill>
+                            <a:srgbClr val="0F172A"/>
+                          </a:solidFill>
+                          <a:latin typeface="Calibri"/>
+                        </a:rPr>
+                        <a:t>-6</a:t>
+                      </a:r>
+                    </a:p>
+                  </a:txBody>
+                  <a:tcPr anchor="ctr" marL="38100" marR="38100" marT="12700" marB="12700">
+                    <a:solidFill>
+                      <a:srgbClr val="FFFFFF"/>
+                    </a:solidFill>
+                  </a:tcPr>
+                </a:tc>
+                <a:tc>
+                  <a:txBody>
+                    <a:bodyPr/>
+                    <a:lstStyle/>
+                    <a:p>
+                      <a:pPr algn="ctr"/>
+                      <a:r>
+                        <a:rPr sz="1050" b="0">
+                          <a:solidFill>
+                            <a:srgbClr val="0F172A"/>
+                          </a:solidFill>
+                          <a:latin typeface="Calibri"/>
+                        </a:rPr>
+                        <a:t>-2</a:t>
+                      </a:r>
+                    </a:p>
+                  </a:txBody>
+                  <a:tcPr anchor="ctr" marL="38100" marR="38100" marT="12700" marB="12700">
+                    <a:solidFill>
+                      <a:srgbClr val="FFFFFF"/>
+                    </a:solidFill>
+                  </a:tcPr>
+                </a:tc>
+                <a:tc>
+                  <a:txBody>
+                    <a:bodyPr/>
+                    <a:lstStyle/>
+                    <a:p>
+                      <a:pPr algn="ctr"/>
+                      <a:r>
+                        <a:rPr sz="1050" b="1">
+                          <a:solidFill>
+                            <a:srgbClr val="00205B"/>
+                          </a:solidFill>
+                          <a:latin typeface="Calibri"/>
+                        </a:rPr>
+                        <a:t>90/95/94%</a:t>
+                      </a:r>
+                    </a:p>
+                  </a:txBody>
+                  <a:tcPr anchor="ctr" marL="38100" marR="38100" marT="12700" marB="12700">
+                    <a:solidFill>
+                      <a:srgbClr val="FFFFFF"/>
+                    </a:solidFill>
+                  </a:tcPr>
+                </a:tc>
+              </a:tr>
+              <a:tr h="487680">
+                <a:tc>
+                  <a:txBody>
+                    <a:bodyPr/>
+                    <a:lstStyle/>
+                    <a:p>
+                      <a:pPr algn="ctr"/>
+                      <a:r>
+                        <a:rPr sz="1050" b="0">
+                          <a:solidFill>
+                            <a:srgbClr val="0F172A"/>
+                          </a:solidFill>
+                          <a:latin typeface="Calibri"/>
+                        </a:rPr>
+                        <a:t>Verquvo (C) — Frequent Hospitalisation</a:t>
+                      </a:r>
+                    </a:p>
+                  </a:txBody>
+                  <a:tcPr anchor="ctr" marL="38100" marR="38100" marT="12700" marB="12700">
+                    <a:solidFill>
+                      <a:srgbClr val="F8FAFC"/>
+                    </a:solidFill>
+                  </a:tcPr>
+                </a:tc>
+                <a:tc>
+                  <a:txBody>
+                    <a:bodyPr/>
+                    <a:lstStyle/>
+                    <a:p>
+                      <a:pPr algn="ctr"/>
+                      <a:r>
+                        <a:rPr sz="1050" b="0">
+                          <a:solidFill>
+                            <a:srgbClr val="0F172A"/>
+                          </a:solidFill>
+                          <a:latin typeface="Calibri"/>
+                        </a:rPr>
+                        <a:t>9</a:t>
+                      </a:r>
+                    </a:p>
+                  </a:txBody>
+                  <a:tcPr anchor="ctr" marL="38100" marR="38100" marT="12700" marB="12700">
+                    <a:solidFill>
+                      <a:srgbClr val="F8FAFC"/>
+                    </a:solidFill>
+                  </a:tcPr>
+                </a:tc>
+                <a:tc>
+                  <a:txBody>
+                    <a:bodyPr/>
+                    <a:lstStyle/>
+                    <a:p>
+                      <a:pPr algn="ctr"/>
+                      <a:r>
+                        <a:rPr sz="1050" b="0">
+                          <a:solidFill>
+                            <a:srgbClr val="0F172A"/>
+                          </a:solidFill>
+                          <a:latin typeface="Calibri"/>
+                        </a:rPr>
+                        <a:t>15</a:t>
+                      </a:r>
+                    </a:p>
+                  </a:txBody>
+                  <a:tcPr anchor="ctr" marL="38100" marR="38100" marT="12700" marB="12700">
+                    <a:solidFill>
+                      <a:srgbClr val="F8FAFC"/>
+                    </a:solidFill>
+                  </a:tcPr>
+                </a:tc>
+                <a:tc>
+                  <a:txBody>
+                    <a:bodyPr/>
+                    <a:lstStyle/>
+                    <a:p>
+                      <a:pPr algn="ctr"/>
+                      <a:r>
+                        <a:rPr sz="1050" b="0">
+                          <a:solidFill>
+                            <a:srgbClr val="0F172A"/>
+                          </a:solidFill>
+                          <a:latin typeface="Calibri"/>
+                        </a:rPr>
+                        <a:t>19</a:t>
+                      </a:r>
+                    </a:p>
+                  </a:txBody>
+                  <a:tcPr anchor="ctr" marL="38100" marR="38100" marT="12700" marB="12700">
+                    <a:solidFill>
+                      <a:srgbClr val="F8FAFC"/>
+                    </a:solidFill>
+                  </a:tcPr>
+                </a:tc>
+                <a:tc>
+                  <a:txBody>
+                    <a:bodyPr/>
+                    <a:lstStyle/>
+                    <a:p>
+                      <a:pPr algn="ctr"/>
+                      <a:r>
+                        <a:rPr sz="1050" b="0">
+                          <a:solidFill>
+                            <a:srgbClr val="0F172A"/>
+                          </a:solidFill>
+                          <a:latin typeface="Calibri"/>
+                        </a:rPr>
+                        <a:t>25/30/28</a:t>
+                      </a:r>
+                    </a:p>
+                  </a:txBody>
+                  <a:tcPr anchor="ctr" marL="38100" marR="38100" marT="12700" marB="12700">
+                    <a:solidFill>
+                      <a:srgbClr val="F8FAFC"/>
+                    </a:solidFill>
+                  </a:tcPr>
+                </a:tc>
+                <a:tc>
+                  <a:txBody>
+                    <a:bodyPr/>
+                    <a:lstStyle/>
+                    <a:p>
+                      <a:pPr algn="ctr"/>
+                      <a:r>
+                        <a:rPr sz="1050" b="0">
+                          <a:solidFill>
+                            <a:srgbClr val="0F172A"/>
+                          </a:solidFill>
+                          <a:latin typeface="Calibri"/>
+                        </a:rPr>
+                        <a:t>7</a:t>
+                      </a:r>
+                    </a:p>
+                  </a:txBody>
+                  <a:tcPr anchor="ctr" marL="38100" marR="38100" marT="12700" marB="12700">
+                    <a:solidFill>
+                      <a:srgbClr val="F8FAFC"/>
+                    </a:solidFill>
+                  </a:tcPr>
+                </a:tc>
+                <a:tc>
+                  <a:txBody>
+                    <a:bodyPr/>
+                    <a:lstStyle/>
+                    <a:p>
+                      <a:pPr algn="ctr"/>
+                      <a:r>
+                        <a:rPr sz="1050" b="0">
+                          <a:solidFill>
+                            <a:srgbClr val="0F172A"/>
+                          </a:solidFill>
+                          <a:latin typeface="Calibri"/>
+                        </a:rPr>
+                        <a:t>14</a:t>
+                      </a:r>
+                    </a:p>
+                  </a:txBody>
+                  <a:tcPr anchor="ctr" marL="38100" marR="38100" marT="12700" marB="12700">
+                    <a:solidFill>
+                      <a:srgbClr val="F8FAFC"/>
+                    </a:solidFill>
+                  </a:tcPr>
+                </a:tc>
+                <a:tc>
+                  <a:txBody>
+                    <a:bodyPr/>
+                    <a:lstStyle/>
+                    <a:p>
+                      <a:pPr algn="ctr"/>
+                      <a:r>
+                        <a:rPr sz="1050" b="0">
+                          <a:solidFill>
+                            <a:srgbClr val="0F172A"/>
+                          </a:solidFill>
+                          <a:latin typeface="Calibri"/>
+                        </a:rPr>
+                        <a:t>-2</a:t>
+                      </a:r>
+                    </a:p>
+                  </a:txBody>
+                  <a:tcPr anchor="ctr" marL="38100" marR="38100" marT="12700" marB="12700">
+                    <a:solidFill>
+                      <a:srgbClr val="F8FAFC"/>
+                    </a:solidFill>
+                  </a:tcPr>
+                </a:tc>
+                <a:tc>
+                  <a:txBody>
+                    <a:bodyPr/>
+                    <a:lstStyle/>
+                    <a:p>
+                      <a:pPr algn="ctr"/>
+                      <a:r>
+                        <a:rPr sz="1050" b="0">
+                          <a:solidFill>
+                            <a:srgbClr val="0F172A"/>
+                          </a:solidFill>
+                          <a:latin typeface="Calibri"/>
+                        </a:rPr>
+                        <a:t>-3</a:t>
+                      </a:r>
+                    </a:p>
+                  </a:txBody>
+                  <a:tcPr anchor="ctr" marL="38100" marR="38100" marT="12700" marB="12700">
+                    <a:solidFill>
+                      <a:srgbClr val="F8FAFC"/>
+                    </a:solidFill>
+                  </a:tcPr>
+                </a:tc>
+                <a:tc>
+                  <a:txBody>
+                    <a:bodyPr/>
+                    <a:lstStyle/>
+                    <a:p>
+                      <a:pPr algn="ctr"/>
+                      <a:r>
+                        <a:rPr sz="1050" b="1">
+                          <a:solidFill>
+                            <a:srgbClr val="00205B"/>
+                          </a:solidFill>
+                          <a:latin typeface="Calibri"/>
+                        </a:rPr>
+                        <a:t>84/89/87%</a:t>
+                      </a:r>
+                    </a:p>
+                  </a:txBody>
+                  <a:tcPr anchor="ctr" marL="38100" marR="38100" marT="12700" marB="12700">
+                    <a:solidFill>
+                      <a:srgbClr val="F8FAFC"/>
+                    </a:solidFill>
+                  </a:tcPr>
+                </a:tc>
+              </a:tr>
+              <a:tr h="487680">
+                <a:tc>
+                  <a:txBody>
+                    <a:bodyPr/>
+                    <a:lstStyle/>
+                    <a:p>
+                      <a:pPr algn="ctr"/>
+                      <a:r>
+                        <a:rPr sz="1050" b="0">
+                          <a:solidFill>
+                            <a:srgbClr val="0F172A"/>
+                          </a:solidFill>
+                          <a:latin typeface="Calibri"/>
+                        </a:rPr>
+                        <a:t>Entresto (B) — High Risk Despite SoC</a:t>
+                      </a:r>
+                    </a:p>
+                  </a:txBody>
+                  <a:tcPr anchor="ctr" marL="38100" marR="38100" marT="12700" marB="12700">
+                    <a:solidFill>
+                      <a:srgbClr val="FFFFFF"/>
+                    </a:solidFill>
+                  </a:tcPr>
+                </a:tc>
+                <a:tc>
+                  <a:txBody>
+                    <a:bodyPr/>
+                    <a:lstStyle/>
+                    <a:p>
+                      <a:pPr algn="ctr"/>
+                      <a:r>
+                        <a:rPr sz="1050" b="0">
+                          <a:solidFill>
+                            <a:srgbClr val="0F172A"/>
+                          </a:solidFill>
+                          <a:latin typeface="Calibri"/>
+                        </a:rPr>
+                        <a:t>10</a:t>
+                      </a:r>
+                    </a:p>
+                  </a:txBody>
+                  <a:tcPr anchor="ctr" marL="38100" marR="38100" marT="12700" marB="12700">
+                    <a:solidFill>
+                      <a:srgbClr val="FFFFFF"/>
+                    </a:solidFill>
+                  </a:tcPr>
+                </a:tc>
+                <a:tc>
+                  <a:txBody>
+                    <a:bodyPr/>
+                    <a:lstStyle/>
+                    <a:p>
+                      <a:pPr algn="ctr"/>
+                      <a:r>
+                        <a:rPr sz="1050" b="0">
+                          <a:solidFill>
+                            <a:srgbClr val="0F172A"/>
+                          </a:solidFill>
+                          <a:latin typeface="Calibri"/>
+                        </a:rPr>
+                        <a:t>16</a:t>
+                      </a:r>
+                    </a:p>
+                  </a:txBody>
+                  <a:tcPr anchor="ctr" marL="38100" marR="38100" marT="12700" marB="12700">
+                    <a:solidFill>
+                      <a:srgbClr val="FFFFFF"/>
+                    </a:solidFill>
+                  </a:tcPr>
+                </a:tc>
+                <a:tc>
+                  <a:txBody>
+                    <a:bodyPr/>
+                    <a:lstStyle/>
+                    <a:p>
+                      <a:pPr algn="ctr"/>
+                      <a:r>
+                        <a:rPr sz="1050" b="0">
+                          <a:solidFill>
+                            <a:srgbClr val="0F172A"/>
+                          </a:solidFill>
+                          <a:latin typeface="Calibri"/>
+                        </a:rPr>
+                        <a:t>18</a:t>
+                      </a:r>
+                    </a:p>
+                  </a:txBody>
+                  <a:tcPr anchor="ctr" marL="38100" marR="38100" marT="12700" marB="12700">
+                    <a:solidFill>
+                      <a:srgbClr val="FFFFFF"/>
+                    </a:solidFill>
+                  </a:tcPr>
+                </a:tc>
+                <a:tc>
+                  <a:txBody>
+                    <a:bodyPr/>
+                    <a:lstStyle/>
+                    <a:p>
+                      <a:pPr algn="ctr"/>
+                      <a:r>
+                        <a:rPr sz="1050" b="0">
+                          <a:solidFill>
+                            <a:srgbClr val="0F172A"/>
+                          </a:solidFill>
+                          <a:latin typeface="Calibri"/>
+                        </a:rPr>
+                        <a:t>23/30/27</a:t>
+                      </a:r>
+                    </a:p>
+                  </a:txBody>
+                  <a:tcPr anchor="ctr" marL="38100" marR="38100" marT="12700" marB="12700">
+                    <a:solidFill>
+                      <a:srgbClr val="FFFFFF"/>
+                    </a:solidFill>
+                  </a:tcPr>
+                </a:tc>
+                <a:tc>
+                  <a:txBody>
+                    <a:bodyPr/>
+                    <a:lstStyle/>
+                    <a:p>
+                      <a:pPr algn="ctr"/>
+                      <a:r>
+                        <a:rPr sz="1050" b="0">
+                          <a:solidFill>
+                            <a:srgbClr val="0F172A"/>
+                          </a:solidFill>
+                          <a:latin typeface="Calibri"/>
+                        </a:rPr>
+                        <a:t>6</a:t>
+                      </a:r>
+                    </a:p>
+                  </a:txBody>
+                  <a:tcPr anchor="ctr" marL="38100" marR="38100" marT="12700" marB="12700">
+                    <a:solidFill>
+                      <a:srgbClr val="FFFFFF"/>
+                    </a:solidFill>
+                  </a:tcPr>
+                </a:tc>
+                <a:tc>
+                  <a:txBody>
+                    <a:bodyPr/>
+                    <a:lstStyle/>
+                    <a:p>
+                      <a:pPr algn="ctr"/>
+                      <a:r>
+                        <a:rPr sz="1050" b="0">
+                          <a:solidFill>
+                            <a:srgbClr val="0F172A"/>
+                          </a:solidFill>
+                          <a:latin typeface="Calibri"/>
+                        </a:rPr>
+                        <a:t>13</a:t>
+                      </a:r>
+                    </a:p>
+                  </a:txBody>
+                  <a:tcPr anchor="ctr" marL="38100" marR="38100" marT="12700" marB="12700">
+                    <a:solidFill>
+                      <a:srgbClr val="FFFFFF"/>
+                    </a:solidFill>
+                  </a:tcPr>
+                </a:tc>
+                <a:tc>
+                  <a:txBody>
+                    <a:bodyPr/>
+                    <a:lstStyle/>
+                    <a:p>
+                      <a:pPr algn="ctr"/>
+                      <a:r>
+                        <a:rPr sz="1050" b="0">
+                          <a:solidFill>
+                            <a:srgbClr val="0F172A"/>
+                          </a:solidFill>
+                          <a:latin typeface="Calibri"/>
+                        </a:rPr>
+                        <a:t>-3</a:t>
+                      </a:r>
+                    </a:p>
+                  </a:txBody>
+                  <a:tcPr anchor="ctr" marL="38100" marR="38100" marT="12700" marB="12700">
+                    <a:solidFill>
+                      <a:srgbClr val="FFFFFF"/>
+                    </a:solidFill>
+                  </a:tcPr>
+                </a:tc>
+                <a:tc>
+                  <a:txBody>
+                    <a:bodyPr/>
+                    <a:lstStyle/>
+                    <a:p>
+                      <a:pPr algn="ctr"/>
+                      <a:r>
+                        <a:rPr sz="1050" b="0">
+                          <a:solidFill>
+                            <a:srgbClr val="0F172A"/>
+                          </a:solidFill>
+                          <a:latin typeface="Calibri"/>
+                        </a:rPr>
+                        <a:t>-3</a:t>
+                      </a:r>
+                    </a:p>
+                  </a:txBody>
+                  <a:tcPr anchor="ctr" marL="38100" marR="38100" marT="12700" marB="12700">
+                    <a:solidFill>
+                      <a:srgbClr val="FFFFFF"/>
+                    </a:solidFill>
+                  </a:tcPr>
+                </a:tc>
+                <a:tc>
+                  <a:txBody>
+                    <a:bodyPr/>
+                    <a:lstStyle/>
+                    <a:p>
+                      <a:pPr algn="ctr"/>
+                      <a:r>
+                        <a:rPr sz="1050" b="1">
+                          <a:solidFill>
+                            <a:srgbClr val="00205B"/>
+                          </a:solidFill>
+                          <a:latin typeface="Calibri"/>
+                        </a:rPr>
+                        <a:t>80/87/84%</a:t>
+                      </a:r>
+                    </a:p>
+                  </a:txBody>
+                  <a:tcPr anchor="ctr" marL="38100" marR="38100" marT="12700" marB="12700">
+                    <a:solidFill>
+                      <a:srgbClr val="FFFFFF"/>
+                    </a:solidFill>
+                  </a:tcPr>
+                </a:tc>
+              </a:tr>
+              <a:tr h="487680">
+                <a:tc>
+                  <a:txBody>
+                    <a:bodyPr/>
+                    <a:lstStyle/>
+                    <a:p>
+                      <a:pPr algn="ctr"/>
+                      <a:r>
+                        <a:rPr sz="1050" b="0">
+                          <a:solidFill>
+                            <a:srgbClr val="0F172A"/>
+                          </a:solidFill>
+                          <a:latin typeface="Calibri"/>
+                        </a:rPr>
+                        <a:t>Jardiance (E) — Later-Line Severe Unmet Need</a:t>
+                      </a:r>
+                    </a:p>
+                  </a:txBody>
+                  <a:tcPr anchor="ctr" marL="38100" marR="38100" marT="12700" marB="12700">
+                    <a:solidFill>
+                      <a:srgbClr val="F8FAFC"/>
+                    </a:solidFill>
+                  </a:tcPr>
+                </a:tc>
+                <a:tc>
+                  <a:txBody>
+                    <a:bodyPr/>
+                    <a:lstStyle/>
+                    <a:p>
+                      <a:pPr algn="ctr"/>
+                      <a:r>
+                        <a:rPr sz="1050" b="0">
+                          <a:solidFill>
+                            <a:srgbClr val="0F172A"/>
+                          </a:solidFill>
+                          <a:latin typeface="Calibri"/>
+                        </a:rPr>
+                        <a:t>5</a:t>
+                      </a:r>
+                    </a:p>
+                  </a:txBody>
+                  <a:tcPr anchor="ctr" marL="38100" marR="38100" marT="12700" marB="12700">
+                    <a:solidFill>
+                      <a:srgbClr val="F8FAFC"/>
+                    </a:solidFill>
+                  </a:tcPr>
+                </a:tc>
+                <a:tc>
+                  <a:txBody>
+                    <a:bodyPr/>
+                    <a:lstStyle/>
+                    <a:p>
+                      <a:pPr algn="ctr"/>
+                      <a:r>
+                        <a:rPr sz="1050" b="0">
+                          <a:solidFill>
+                            <a:srgbClr val="0F172A"/>
+                          </a:solidFill>
+                          <a:latin typeface="Calibri"/>
+                        </a:rPr>
+                        <a:t>20</a:t>
+                      </a:r>
+                    </a:p>
+                  </a:txBody>
+                  <a:tcPr anchor="ctr" marL="38100" marR="38100" marT="12700" marB="12700">
+                    <a:solidFill>
+                      <a:srgbClr val="F8FAFC"/>
+                    </a:solidFill>
+                  </a:tcPr>
+                </a:tc>
+                <a:tc>
+                  <a:txBody>
+                    <a:bodyPr/>
+                    <a:lstStyle/>
+                    <a:p>
+                      <a:pPr algn="ctr"/>
+                      <a:r>
+                        <a:rPr sz="1050" b="0">
+                          <a:solidFill>
+                            <a:srgbClr val="0F172A"/>
+                          </a:solidFill>
+                          <a:latin typeface="Calibri"/>
+                        </a:rPr>
+                        <a:t>17</a:t>
+                      </a:r>
+                    </a:p>
+                  </a:txBody>
+                  <a:tcPr anchor="ctr" marL="38100" marR="38100" marT="12700" marB="12700">
+                    <a:solidFill>
+                      <a:srgbClr val="F8FAFC"/>
+                    </a:solidFill>
+                  </a:tcPr>
+                </a:tc>
+                <a:tc>
+                  <a:txBody>
+                    <a:bodyPr/>
+                    <a:lstStyle/>
+                    <a:p>
+                      <a:pPr algn="ctr"/>
+                      <a:r>
+                        <a:rPr sz="1050" b="0">
+                          <a:solidFill>
+                            <a:srgbClr val="0F172A"/>
+                          </a:solidFill>
+                          <a:latin typeface="Calibri"/>
+                        </a:rPr>
+                        <a:t>24/28/28</a:t>
+                      </a:r>
+                    </a:p>
+                  </a:txBody>
+                  <a:tcPr anchor="ctr" marL="38100" marR="38100" marT="12700" marB="12700">
+                    <a:solidFill>
+                      <a:srgbClr val="F8FAFC"/>
+                    </a:solidFill>
+                  </a:tcPr>
+                </a:tc>
+                <a:tc>
+                  <a:txBody>
+                    <a:bodyPr/>
+                    <a:lstStyle/>
+                    <a:p>
+                      <a:pPr algn="ctr"/>
+                      <a:r>
+                        <a:rPr sz="1050" b="0">
+                          <a:solidFill>
+                            <a:srgbClr val="0F172A"/>
+                          </a:solidFill>
+                          <a:latin typeface="Calibri"/>
+                        </a:rPr>
+                        <a:t>9</a:t>
+                      </a:r>
+                    </a:p>
+                  </a:txBody>
+                  <a:tcPr anchor="ctr" marL="38100" marR="38100" marT="12700" marB="12700">
+                    <a:solidFill>
+                      <a:srgbClr val="F8FAFC"/>
+                    </a:solidFill>
+                  </a:tcPr>
+                </a:tc>
+                <a:tc>
+                  <a:txBody>
+                    <a:bodyPr/>
+                    <a:lstStyle/>
+                    <a:p>
+                      <a:pPr algn="ctr"/>
+                      <a:r>
+                        <a:rPr sz="1050" b="0">
+                          <a:solidFill>
+                            <a:srgbClr val="0F172A"/>
+                          </a:solidFill>
+                          <a:latin typeface="Calibri"/>
+                        </a:rPr>
+                        <a:t>11</a:t>
+                      </a:r>
+                    </a:p>
+                  </a:txBody>
+                  <a:tcPr anchor="ctr" marL="38100" marR="38100" marT="12700" marB="12700">
+                    <a:solidFill>
+                      <a:srgbClr val="F8FAFC"/>
+                    </a:solidFill>
+                  </a:tcPr>
+                </a:tc>
+                <a:tc>
+                  <a:txBody>
+                    <a:bodyPr/>
+                    <a:lstStyle/>
+                    <a:p>
+                      <a:pPr algn="ctr"/>
+                      <a:r>
+                        <a:rPr sz="1050" b="0">
+                          <a:solidFill>
+                            <a:srgbClr val="0F172A"/>
+                          </a:solidFill>
+                          <a:latin typeface="Calibri"/>
+                        </a:rPr>
+                        <a:t>-4</a:t>
+                      </a:r>
+                    </a:p>
+                  </a:txBody>
+                  <a:tcPr anchor="ctr" marL="38100" marR="38100" marT="12700" marB="12700">
+                    <a:solidFill>
+                      <a:srgbClr val="F8FAFC"/>
+                    </a:solidFill>
+                  </a:tcPr>
+                </a:tc>
+                <a:tc>
+                  <a:txBody>
+                    <a:bodyPr/>
+                    <a:lstStyle/>
+                    <a:p>
+                      <a:pPr algn="ctr"/>
+                      <a:r>
+                        <a:rPr sz="1050" b="0">
+                          <a:solidFill>
+                            <a:srgbClr val="0F172A"/>
+                          </a:solidFill>
+                          <a:latin typeface="Calibri"/>
+                        </a:rPr>
+                        <a:t>-5</a:t>
+                      </a:r>
+                    </a:p>
+                  </a:txBody>
+                  <a:tcPr anchor="ctr" marL="38100" marR="38100" marT="12700" marB="12700">
+                    <a:solidFill>
+                      <a:srgbClr val="F8FAFC"/>
+                    </a:solidFill>
+                  </a:tcPr>
+                </a:tc>
+                <a:tc>
+                  <a:txBody>
+                    <a:bodyPr/>
+                    <a:lstStyle/>
+                    <a:p>
+                      <a:pPr algn="ctr"/>
+                      <a:r>
+                        <a:rPr sz="1050" b="1">
+                          <a:solidFill>
+                            <a:srgbClr val="00205B"/>
+                          </a:solidFill>
+                          <a:latin typeface="Calibri"/>
+                        </a:rPr>
+                        <a:t>77/81/81%</a:t>
+                      </a:r>
+                    </a:p>
+                  </a:txBody>
+                  <a:tcPr anchor="ctr" marL="38100" marR="38100" marT="12700" marB="12700">
+                    <a:solidFill>
+                      <a:srgbClr val="F8FAFC"/>
+                    </a:solidFill>
+                  </a:tcPr>
+                </a:tc>
+              </a:tr>
+              <a:tr h="487680">
+                <a:tc>
+                  <a:txBody>
+                    <a:bodyPr/>
+                    <a:lstStyle/>
+                    <a:p>
+                      <a:pPr algn="ctr"/>
+                      <a:r>
+                        <a:rPr sz="1050" b="0">
+                          <a:solidFill>
+                            <a:srgbClr val="0F172A"/>
+                          </a:solidFill>
+                          <a:latin typeface="Calibri"/>
+                        </a:rPr>
+                        <a:t>Broad Class (A) — Broad HF Population</a:t>
+                      </a:r>
+                    </a:p>
+                  </a:txBody>
+                  <a:tcPr anchor="ctr" marL="38100" marR="38100" marT="12700" marB="12700">
+                    <a:solidFill>
+                      <a:srgbClr val="FFFFFF"/>
+                    </a:solidFill>
+                  </a:tcPr>
+                </a:tc>
+                <a:tc>
+                  <a:txBody>
+                    <a:bodyPr/>
+                    <a:lstStyle/>
+                    <a:p>
+                      <a:pPr algn="ctr"/>
+                      <a:r>
+                        <a:rPr sz="1050" b="0">
+                          <a:solidFill>
+                            <a:srgbClr val="0F172A"/>
+                          </a:solidFill>
+                          <a:latin typeface="Calibri"/>
+                        </a:rPr>
+                        <a:t>14</a:t>
+                      </a:r>
+                    </a:p>
+                  </a:txBody>
+                  <a:tcPr anchor="ctr" marL="38100" marR="38100" marT="12700" marB="12700">
+                    <a:solidFill>
+                      <a:srgbClr val="FFFFFF"/>
+                    </a:solidFill>
+                  </a:tcPr>
+                </a:tc>
+                <a:tc>
+                  <a:txBody>
+                    <a:bodyPr/>
+                    <a:lstStyle/>
+                    <a:p>
+                      <a:pPr algn="ctr"/>
+                      <a:r>
+                        <a:rPr sz="1050" b="0">
+                          <a:solidFill>
+                            <a:srgbClr val="0F172A"/>
+                          </a:solidFill>
+                          <a:latin typeface="Calibri"/>
+                        </a:rPr>
+                        <a:t>10</a:t>
+                      </a:r>
+                    </a:p>
+                  </a:txBody>
+                  <a:tcPr anchor="ctr" marL="38100" marR="38100" marT="12700" marB="12700">
+                    <a:solidFill>
+                      <a:srgbClr val="FFFFFF"/>
+                    </a:solidFill>
+                  </a:tcPr>
+                </a:tc>
+                <a:tc>
+                  <a:txBody>
+                    <a:bodyPr/>
+                    <a:lstStyle/>
+                    <a:p>
+                      <a:pPr algn="ctr"/>
+                      <a:r>
+                        <a:rPr sz="1050" b="0">
+                          <a:solidFill>
+                            <a:srgbClr val="0F172A"/>
+                          </a:solidFill>
+                          <a:latin typeface="Calibri"/>
+                        </a:rPr>
+                        <a:t>14</a:t>
+                      </a:r>
+                    </a:p>
+                  </a:txBody>
+                  <a:tcPr anchor="ctr" marL="38100" marR="38100" marT="12700" marB="12700">
+                    <a:solidFill>
+                      <a:srgbClr val="FFFFFF"/>
+                    </a:solidFill>
+                  </a:tcPr>
+                </a:tc>
+                <a:tc>
+                  <a:txBody>
+                    <a:bodyPr/>
+                    <a:lstStyle/>
+                    <a:p>
+                      <a:pPr algn="ctr"/>
+                      <a:r>
+                        <a:rPr sz="1050" b="0">
+                          <a:solidFill>
+                            <a:srgbClr val="0F172A"/>
+                          </a:solidFill>
+                          <a:latin typeface="Calibri"/>
+                        </a:rPr>
+                        <a:t>17/23/20</a:t>
+                      </a:r>
+                    </a:p>
+                  </a:txBody>
+                  <a:tcPr anchor="ctr" marL="38100" marR="38100" marT="12700" marB="12700">
+                    <a:solidFill>
+                      <a:srgbClr val="FFFFFF"/>
+                    </a:solidFill>
+                  </a:tcPr>
+                </a:tc>
+                <a:tc>
+                  <a:txBody>
+                    <a:bodyPr/>
+                    <a:lstStyle/>
+                    <a:p>
+                      <a:pPr algn="ctr"/>
+                      <a:r>
+                        <a:rPr sz="1050" b="0">
+                          <a:solidFill>
+                            <a:srgbClr val="0F172A"/>
+                          </a:solidFill>
+                          <a:latin typeface="Calibri"/>
+                        </a:rPr>
+                        <a:t>3</a:t>
+                      </a:r>
+                    </a:p>
+                  </a:txBody>
+                  <a:tcPr anchor="ctr" marL="38100" marR="38100" marT="12700" marB="12700">
+                    <a:solidFill>
+                      <a:srgbClr val="FFFFFF"/>
+                    </a:solidFill>
+                  </a:tcPr>
+                </a:tc>
+                <a:tc>
+                  <a:txBody>
+                    <a:bodyPr/>
+                    <a:lstStyle/>
+                    <a:p>
+                      <a:pPr algn="ctr"/>
+                      <a:r>
+                        <a:rPr sz="1050" b="0">
+                          <a:solidFill>
+                            <a:srgbClr val="0F172A"/>
+                          </a:solidFill>
+                          <a:latin typeface="Calibri"/>
+                        </a:rPr>
+                        <a:t>12</a:t>
+                      </a:r>
+                    </a:p>
+                  </a:txBody>
+                  <a:tcPr anchor="ctr" marL="38100" marR="38100" marT="12700" marB="12700">
+                    <a:solidFill>
+                      <a:srgbClr val="FFFFFF"/>
+                    </a:solidFill>
+                  </a:tcPr>
+                </a:tc>
+                <a:tc>
+                  <a:txBody>
+                    <a:bodyPr/>
+                    <a:lstStyle/>
+                    <a:p>
+                      <a:pPr algn="ctr"/>
+                      <a:r>
+                        <a:rPr sz="1050" b="0">
+                          <a:solidFill>
+                            <a:srgbClr val="0F172A"/>
+                          </a:solidFill>
+                          <a:latin typeface="Calibri"/>
+                        </a:rPr>
+                        <a:t>-2</a:t>
+                      </a:r>
+                    </a:p>
+                  </a:txBody>
+                  <a:tcPr anchor="ctr" marL="38100" marR="38100" marT="12700" marB="12700">
+                    <a:solidFill>
+                      <a:srgbClr val="FFFFFF"/>
+                    </a:solidFill>
+                  </a:tcPr>
+                </a:tc>
+                <a:tc>
+                  <a:txBody>
+                    <a:bodyPr/>
+                    <a:lstStyle/>
+                    <a:p>
+                      <a:pPr algn="ctr"/>
+                      <a:r>
+                        <a:rPr sz="1050" b="0">
+                          <a:solidFill>
+                            <a:srgbClr val="0F172A"/>
+                          </a:solidFill>
+                          <a:latin typeface="Calibri"/>
+                        </a:rPr>
+                        <a:t>-4</a:t>
+                      </a:r>
+                    </a:p>
+                  </a:txBody>
+                  <a:tcPr anchor="ctr" marL="38100" marR="38100" marT="12700" marB="12700">
+                    <a:solidFill>
+                      <a:srgbClr val="FFFFFF"/>
+                    </a:solidFill>
+                  </a:tcPr>
+                </a:tc>
+                <a:tc>
+                  <a:txBody>
+                    <a:bodyPr/>
+                    <a:lstStyle/>
+                    <a:p>
+                      <a:pPr algn="ctr"/>
+                      <a:r>
+                        <a:rPr sz="1050" b="1">
+                          <a:solidFill>
+                            <a:srgbClr val="00205B"/>
+                          </a:solidFill>
+                          <a:latin typeface="Calibri"/>
+                        </a:rPr>
+                        <a:t>64/70/67%</a:t>
+                      </a:r>
+                    </a:p>
+                  </a:txBody>
+                  <a:tcPr anchor="ctr" marL="38100" marR="38100" marT="12700" marB="12700">
+                    <a:solidFill>
+                      <a:srgbClr val="FFFFFF"/>
+                    </a:solidFill>
+                  </a:tcPr>
+                </a:tc>
+              </a:tr>
+            </a:tbl>
+          </a:graphicData>
+        </a:graphic>
+      </p:graphicFrame>
+      <p:sp>
+        <p:nvSpPr>
+          <p:cNvPr id="9" name="Rounded Rectangle 8"/>
+          <p:cNvSpPr/>
+          <p:nvPr/>
+        </p:nvSpPr>
+        <p:spPr>
+          <a:xfrm>
+            <a:off x="548640" y="5120640"/>
+            <a:ext cx="11109960" cy="1280160"/>
+          </a:xfrm>
+          <a:prstGeom prst="roundRect">
+            <a:avLst>
+              <a:gd name="adj" fmla="val 6000"/>
+            </a:avLst>
+          </a:prstGeom>
+          <a:solidFill>
+            <a:srgbClr val="F8FAFC"/>
+          </a:solidFill>
+          <a:ln w="12700">
+            <a:solidFill>
+              <a:srgbClr val="E2E8F0"/>
+            </a:solidFill>
+          </a:ln>
+          <a:effectLst/>
+        </p:spPr>
+        <p:style>
+          <a:lnRef idx="1">
+            <a:schemeClr val="accent1"/>
+          </a:lnRef>
+          <a:fillRef idx="3">
+            <a:schemeClr val="accent1"/>
+          </a:fillRef>
+          <a:effectRef idx="2">
+            <a:schemeClr val="accent1"/>
+          </a:effectRef>
+          <a:fontRef idx="minor">
+            <a:schemeClr val="lt1"/>
+          </a:fontRef>
+        </p:style>
+        <p:txBody>
+          <a:bodyPr rtlCol="0" anchor="ctr"/>
+          <a:lstStyle/>
+          <a:p>
+            <a:pPr algn="ctr"/>
+          </a:p>
+        </p:txBody>
+      </p:sp>
+      <p:sp>
+        <p:nvSpPr>
+          <p:cNvPr id="10" name="TextBox 9"/>
+          <p:cNvSpPr txBox="1"/>
+          <p:nvPr/>
+        </p:nvSpPr>
+        <p:spPr>
+          <a:xfrm>
+            <a:off x="777240" y="5257800"/>
+            <a:ext cx="10607040" cy="274320"/>
+          </a:xfrm>
+          <a:prstGeom prst="rect">
+            <a:avLst/>
+          </a:prstGeom>
+          <a:noFill/>
+        </p:spPr>
+        <p:txBody>
+          <a:bodyPr wrap="square" anchor="t" lIns="0" rIns="0" tIns="0" bIns="0">
+            <a:spAutoFit/>
+          </a:bodyPr>
+          <a:lstStyle/>
+          <a:p>
+            <a:pPr algn="l">
+              <a:lnSpc>
+                <a:spcPct val="100000"/>
+              </a:lnSpc>
+            </a:pPr>
+            <a:r>
+              <a:rPr sz="1150" b="1" i="0">
+                <a:solidFill>
+                  <a:srgbClr val="00205B"/>
+                </a:solidFill>
+                <a:latin typeface="Calibri"/>
+              </a:rPr>
+              <a:t>Verification example (Scenario D, Germany):</a:t>
+            </a:r>
+          </a:p>
+        </p:txBody>
+      </p:sp>
+      <p:sp>
+        <p:nvSpPr>
+          <p:cNvPr id="11" name="TextBox 10"/>
+          <p:cNvSpPr txBox="1"/>
+          <p:nvPr/>
+        </p:nvSpPr>
+        <p:spPr>
+          <a:xfrm>
+            <a:off x="777240" y="5532120"/>
+            <a:ext cx="10607040" cy="274320"/>
+          </a:xfrm>
+          <a:prstGeom prst="rect">
+            <a:avLst/>
+          </a:prstGeom>
+          <a:noFill/>
+        </p:spPr>
+        <p:txBody>
+          <a:bodyPr wrap="square" anchor="t" lIns="0" rIns="0" tIns="0" bIns="0">
+            <a:spAutoFit/>
+          </a:bodyPr>
+          <a:lstStyle/>
+          <a:p>
+            <a:pPr algn="l">
+              <a:lnSpc>
+                <a:spcPct val="100000"/>
+              </a:lnSpc>
+            </a:pPr>
+            <a:r>
+              <a:rPr sz="1150" b="0" i="0">
+                <a:solidFill>
+                  <a:srgbClr val="0F172A"/>
+                </a:solidFill>
+                <a:latin typeface="Calibri"/>
+              </a:rPr>
+              <a:t>8 (P) + 18 (U) + 22 (C) + 32 (A) + 8 (F) + 15 (E) − 6 (G_impl) − 2 (G_evid)  =  95%  ✓ matches the published German probability exactly.</a:t>
+            </a:r>
+          </a:p>
+        </p:txBody>
+      </p:sp>
+      <p:sp>
+        <p:nvSpPr>
+          <p:cNvPr id="12" name="TextBox 11"/>
+          <p:cNvSpPr txBox="1"/>
+          <p:nvPr/>
+        </p:nvSpPr>
+        <p:spPr>
+          <a:xfrm>
+            <a:off x="777240" y="5852160"/>
+            <a:ext cx="10607040" cy="457200"/>
+          </a:xfrm>
+          <a:prstGeom prst="rect">
+            <a:avLst/>
+          </a:prstGeom>
+          <a:noFill/>
+        </p:spPr>
+        <p:txBody>
+          <a:bodyPr wrap="square" anchor="t" lIns="0" rIns="0" tIns="0" bIns="0">
+            <a:spAutoFit/>
+          </a:bodyPr>
+          <a:lstStyle/>
+          <a:p>
+            <a:pPr algn="l">
+              <a:lnSpc>
+                <a:spcPct val="100000"/>
+              </a:lnSpc>
+            </a:pPr>
+            <a:r>
+              <a:rPr sz="1050" b="0" i="1">
+                <a:solidFill>
+                  <a:srgbClr val="475569"/>
+                </a:solidFill>
+                <a:latin typeface="Calibri"/>
+              </a:rPr>
+              <a:t>Pattern: A(Germany) ≥ A(France) ≥ A(UK) in every scenario — Germany's added-benefit-only AMNOG process rewards evidence alignment most directly; the UK's hard ICER ceiling constrains it most.</a:t>
+            </a:r>
+          </a:p>
+        </p:txBody>
+      </p:sp>
+      <p:sp>
+        <p:nvSpPr>
+          <p:cNvPr id="13" name="TextBox 12"/>
+          <p:cNvSpPr txBox="1"/>
+          <p:nvPr/>
+        </p:nvSpPr>
+        <p:spPr>
+          <a:xfrm>
+            <a:off x="548640" y="6565392"/>
+            <a:ext cx="9144000" cy="256032"/>
+          </a:xfrm>
+          <a:prstGeom prst="rect">
+            <a:avLst/>
+          </a:prstGeom>
+          <a:noFill/>
+        </p:spPr>
+        <p:txBody>
+          <a:bodyPr wrap="square" anchor="t" lIns="0" rIns="0" tIns="0" bIns="0">
+            <a:spAutoFit/>
+          </a:bodyPr>
+          <a:lstStyle/>
+          <a:p>
+            <a:pPr algn="l">
+              <a:lnSpc>
+                <a:spcPct val="100000"/>
+              </a:lnSpc>
+            </a:pPr>
+            <a:r>
+              <a:rPr sz="900" b="0" i="0">
+                <a:solidFill>
+                  <a:srgbClr val="94A3B8"/>
+                </a:solidFill>
+                <a:latin typeface="Calibri"/>
+              </a:rPr>
+              <a:t>PayerLens AI  •  Response to pre-finale review — scoring methodology appendix</a:t>
             </a:r>
           </a:p>
         </p:txBody>

</xml_diff>